<commit_message>
Added Data Quality pages to Power BI dashboard
   - Added pages 5-6: Data Quality Monitoring and Flag Review Workbench
   - Created 6 new DAX measures for flag tracking
   - Captured 3 new screenshots (2 pages + data model)
   - Updated documentation with technical achievements
   - 85% project completion (Week 3 finished)"
</commit_message>
<xml_diff>
--- a/power-apps/wireframes/wireframes-dataquality-portal.pptx
+++ b/power-apps/wireframes/wireframes-dataquality-portal.pptx
@@ -133,7 +133,7 @@
 <file path=ppt/revisionInfo.xml><?xml version="1.0" encoding="utf-8"?>
 <p1510:revInfo xmlns:a="http://schemas.openxmlformats.org/drawingml/2006/main" xmlns:r="http://schemas.openxmlformats.org/officeDocument/2006/relationships" xmlns:p1510="http://schemas.microsoft.com/office/powerpoint/2015/10/main">
   <p1510:revLst>
-    <p1510:client id="{3C004701-1004-425E-95F2-4F810687766F}" v="233" dt="2025-11-24T22:12:24.741"/>
+    <p1510:client id="{A6BF6FE8-F662-403E-A3DD-534F4B061CC5}" v="2" dt="2025-12-14T01:54:36.850"/>
   </p1510:revLst>
 </p1510:revInfo>
 </file>
@@ -143,7 +143,7 @@
   <pc:docChgLst>
     <pc:chgData name="John Rolzhausen" userId="f0fced98129e348e" providerId="LiveId" clId="{FAB81778-C2AB-48D5-BA9E-3E19BB729E3D}"/>
     <pc:docChg chg="undo redo custSel addSld delSld modSld sldOrd">
-      <pc:chgData name="John Rolzhausen" userId="f0fced98129e348e" providerId="LiveId" clId="{FAB81778-C2AB-48D5-BA9E-3E19BB729E3D}" dt="2025-11-24T22:13:46.165" v="3059" actId="6549"/>
+      <pc:chgData name="John Rolzhausen" userId="f0fced98129e348e" providerId="LiveId" clId="{FAB81778-C2AB-48D5-BA9E-3E19BB729E3D}" dt="2025-12-15T21:31:38.931" v="3076" actId="6549"/>
       <pc:docMkLst>
         <pc:docMk/>
       </pc:docMkLst>
@@ -170,93 +170,8 @@
           </ac:spMkLst>
         </pc:spChg>
       </pc:sldChg>
-      <pc:sldChg chg="modSp del">
-        <pc:chgData name="John Rolzhausen" userId="f0fced98129e348e" providerId="LiveId" clId="{FAB81778-C2AB-48D5-BA9E-3E19BB729E3D}" dt="2025-11-24T18:20:24.331" v="703" actId="47"/>
-        <pc:sldMkLst>
-          <pc:docMk/>
-          <pc:sldMk cId="2091095100" sldId="258"/>
-        </pc:sldMkLst>
-        <pc:spChg chg="mod">
-          <ac:chgData name="John Rolzhausen" userId="f0fced98129e348e" providerId="LiveId" clId="{FAB81778-C2AB-48D5-BA9E-3E19BB729E3D}" dt="2025-11-24T17:34:01.249" v="2"/>
-          <ac:spMkLst>
-            <pc:docMk/>
-            <pc:sldMk cId="2091095100" sldId="258"/>
-            <ac:spMk id="2" creationId="{6E3A468F-0DCF-3907-88A2-D68E41E3ACAF}"/>
-          </ac:spMkLst>
-        </pc:spChg>
-        <pc:spChg chg="mod">
-          <ac:chgData name="John Rolzhausen" userId="f0fced98129e348e" providerId="LiveId" clId="{FAB81778-C2AB-48D5-BA9E-3E19BB729E3D}" dt="2025-11-24T17:34:11.847" v="3"/>
-          <ac:spMkLst>
-            <pc:docMk/>
-            <pc:sldMk cId="2091095100" sldId="258"/>
-            <ac:spMk id="3" creationId="{1C3CA14A-DF49-C8C3-3927-CA8B3C4DA760}"/>
-          </ac:spMkLst>
-        </pc:spChg>
-        <pc:spChg chg="mod">
-          <ac:chgData name="John Rolzhausen" userId="f0fced98129e348e" providerId="LiveId" clId="{FAB81778-C2AB-48D5-BA9E-3E19BB729E3D}" dt="2025-11-24T17:35:14.629" v="5"/>
-          <ac:spMkLst>
-            <pc:docMk/>
-            <pc:sldMk cId="2091095100" sldId="258"/>
-            <ac:spMk id="13" creationId="{A5AAE938-6BD5-1D78-A1E3-F451C06A7204}"/>
-          </ac:spMkLst>
-        </pc:spChg>
-      </pc:sldChg>
-      <pc:sldChg chg="delSp modSp add del mod">
-        <pc:chgData name="John Rolzhausen" userId="f0fced98129e348e" providerId="LiveId" clId="{FAB81778-C2AB-48D5-BA9E-3E19BB729E3D}" dt="2025-11-24T19:50:54.474" v="1503" actId="47"/>
-        <pc:sldMkLst>
-          <pc:docMk/>
-          <pc:sldMk cId="1979496785" sldId="259"/>
-        </pc:sldMkLst>
-        <pc:spChg chg="mod">
-          <ac:chgData name="John Rolzhausen" userId="f0fced98129e348e" providerId="LiveId" clId="{FAB81778-C2AB-48D5-BA9E-3E19BB729E3D}" dt="2025-11-24T19:49:56.694" v="1495"/>
-          <ac:spMkLst>
-            <pc:docMk/>
-            <pc:sldMk cId="1979496785" sldId="259"/>
-            <ac:spMk id="2" creationId="{7EAA8AB5-C290-B8FA-5E3D-D0FAEF3A2D8D}"/>
-          </ac:spMkLst>
-        </pc:spChg>
-        <pc:spChg chg="mod">
-          <ac:chgData name="John Rolzhausen" userId="f0fced98129e348e" providerId="LiveId" clId="{FAB81778-C2AB-48D5-BA9E-3E19BB729E3D}" dt="2025-11-24T19:50:20.445" v="1497"/>
-          <ac:spMkLst>
-            <pc:docMk/>
-            <pc:sldMk cId="1979496785" sldId="259"/>
-            <ac:spMk id="3" creationId="{109FC576-B021-E9C6-A5A6-B769531D896C}"/>
-          </ac:spMkLst>
-        </pc:spChg>
-        <pc:spChg chg="del mod">
-          <ac:chgData name="John Rolzhausen" userId="f0fced98129e348e" providerId="LiveId" clId="{FAB81778-C2AB-48D5-BA9E-3E19BB729E3D}" dt="2025-11-24T19:50:37.364" v="1500" actId="478"/>
-          <ac:spMkLst>
-            <pc:docMk/>
-            <pc:sldMk cId="1979496785" sldId="259"/>
-            <ac:spMk id="5" creationId="{D49680CF-5B59-8BC6-B8D8-CE916567189E}"/>
-          </ac:spMkLst>
-        </pc:spChg>
-        <pc:spChg chg="del">
-          <ac:chgData name="John Rolzhausen" userId="f0fced98129e348e" providerId="LiveId" clId="{FAB81778-C2AB-48D5-BA9E-3E19BB729E3D}" dt="2025-11-24T19:50:34.046" v="1498" actId="478"/>
-          <ac:spMkLst>
-            <pc:docMk/>
-            <pc:sldMk cId="1979496785" sldId="259"/>
-            <ac:spMk id="7" creationId="{6F67D9D7-CF6F-1B7F-338B-20BB6E2D95A5}"/>
-          </ac:spMkLst>
-        </pc:spChg>
-        <pc:spChg chg="del mod">
-          <ac:chgData name="John Rolzhausen" userId="f0fced98129e348e" providerId="LiveId" clId="{FAB81778-C2AB-48D5-BA9E-3E19BB729E3D}" dt="2025-11-24T19:50:39.213" v="1502" actId="478"/>
-          <ac:spMkLst>
-            <pc:docMk/>
-            <pc:sldMk cId="1979496785" sldId="259"/>
-            <ac:spMk id="13" creationId="{D72163F6-B949-081B-003A-3D62CA8200A5}"/>
-          </ac:spMkLst>
-        </pc:spChg>
-      </pc:sldChg>
-      <pc:sldChg chg="del">
-        <pc:chgData name="John Rolzhausen" userId="f0fced98129e348e" providerId="LiveId" clId="{FAB81778-C2AB-48D5-BA9E-3E19BB729E3D}" dt="2025-11-24T18:20:27.662" v="705" actId="47"/>
-        <pc:sldMkLst>
-          <pc:docMk/>
-          <pc:sldMk cId="3467722913" sldId="260"/>
-        </pc:sldMkLst>
-      </pc:sldChg>
       <pc:sldChg chg="addSp delSp modSp add del mod ord">
-        <pc:chgData name="John Rolzhausen" userId="f0fced98129e348e" providerId="LiveId" clId="{FAB81778-C2AB-48D5-BA9E-3E19BB729E3D}" dt="2025-11-24T18:16:59.568" v="702" actId="255"/>
+        <pc:chgData name="John Rolzhausen" userId="f0fced98129e348e" providerId="LiveId" clId="{FAB81778-C2AB-48D5-BA9E-3E19BB729E3D}" dt="2025-12-15T20:29:27.391" v="3074" actId="6549"/>
         <pc:sldMkLst>
           <pc:docMk/>
           <pc:sldMk cId="343244891" sldId="261"/>
@@ -275,38 +190,6 @@
             <pc:docMk/>
             <pc:sldMk cId="343244891" sldId="261"/>
             <ac:spMk id="3" creationId="{7CA2AD9E-B2F2-D73D-E047-C834F9D1EBA2}"/>
-          </ac:spMkLst>
-        </pc:spChg>
-        <pc:spChg chg="del">
-          <ac:chgData name="John Rolzhausen" userId="f0fced98129e348e" providerId="LiveId" clId="{FAB81778-C2AB-48D5-BA9E-3E19BB729E3D}" dt="2025-11-24T17:59:36.461" v="507" actId="478"/>
-          <ac:spMkLst>
-            <pc:docMk/>
-            <pc:sldMk cId="343244891" sldId="261"/>
-            <ac:spMk id="4" creationId="{5DCD58B5-D537-0F78-8CC0-5594209548E5}"/>
-          </ac:spMkLst>
-        </pc:spChg>
-        <pc:spChg chg="del mod">
-          <ac:chgData name="John Rolzhausen" userId="f0fced98129e348e" providerId="LiveId" clId="{FAB81778-C2AB-48D5-BA9E-3E19BB729E3D}" dt="2025-11-24T17:55:49.777" v="123" actId="478"/>
-          <ac:spMkLst>
-            <pc:docMk/>
-            <pc:sldMk cId="343244891" sldId="261"/>
-            <ac:spMk id="5" creationId="{611A99E5-FB16-413D-EA42-E3712356A182}"/>
-          </ac:spMkLst>
-        </pc:spChg>
-        <pc:spChg chg="del">
-          <ac:chgData name="John Rolzhausen" userId="f0fced98129e348e" providerId="LiveId" clId="{FAB81778-C2AB-48D5-BA9E-3E19BB729E3D}" dt="2025-11-24T17:59:37.423" v="508" actId="478"/>
-          <ac:spMkLst>
-            <pc:docMk/>
-            <pc:sldMk cId="343244891" sldId="261"/>
-            <ac:spMk id="6" creationId="{42020D29-CC33-8E79-DD7B-B9B4A7E9DE1F}"/>
-          </ac:spMkLst>
-        </pc:spChg>
-        <pc:spChg chg="del">
-          <ac:chgData name="John Rolzhausen" userId="f0fced98129e348e" providerId="LiveId" clId="{FAB81778-C2AB-48D5-BA9E-3E19BB729E3D}" dt="2025-11-24T17:55:46.041" v="121" actId="478"/>
-          <ac:spMkLst>
-            <pc:docMk/>
-            <pc:sldMk cId="343244891" sldId="261"/>
-            <ac:spMk id="7" creationId="{883337EA-4CBF-78D4-A90B-4AC8AAA120E1}"/>
           </ac:spMkLst>
         </pc:spChg>
         <pc:spChg chg="mod">
@@ -333,38 +216,6 @@
             <ac:spMk id="10" creationId="{2776EADC-8101-1CDE-8FB3-51BAB8DC53DD}"/>
           </ac:spMkLst>
         </pc:spChg>
-        <pc:spChg chg="del mod">
-          <ac:chgData name="John Rolzhausen" userId="f0fced98129e348e" providerId="LiveId" clId="{FAB81778-C2AB-48D5-BA9E-3E19BB729E3D}" dt="2025-11-24T18:07:04.345" v="642" actId="478"/>
-          <ac:spMkLst>
-            <pc:docMk/>
-            <pc:sldMk cId="343244891" sldId="261"/>
-            <ac:spMk id="11" creationId="{236EA23E-3481-2923-B63E-7C65A236FBA6}"/>
-          </ac:spMkLst>
-        </pc:spChg>
-        <pc:spChg chg="del">
-          <ac:chgData name="John Rolzhausen" userId="f0fced98129e348e" providerId="LiveId" clId="{FAB81778-C2AB-48D5-BA9E-3E19BB729E3D}" dt="2025-11-24T17:59:33.840" v="505" actId="478"/>
-          <ac:spMkLst>
-            <pc:docMk/>
-            <pc:sldMk cId="343244891" sldId="261"/>
-            <ac:spMk id="12" creationId="{98C13204-E8F0-6710-CBA9-206DC095A8D4}"/>
-          </ac:spMkLst>
-        </pc:spChg>
-        <pc:spChg chg="del mod">
-          <ac:chgData name="John Rolzhausen" userId="f0fced98129e348e" providerId="LiveId" clId="{FAB81778-C2AB-48D5-BA9E-3E19BB729E3D}" dt="2025-11-24T17:55:51.680" v="124" actId="478"/>
-          <ac:spMkLst>
-            <pc:docMk/>
-            <pc:sldMk cId="343244891" sldId="261"/>
-            <ac:spMk id="13" creationId="{2BA1B598-3395-F5E9-E842-48268CD87709}"/>
-          </ac:spMkLst>
-        </pc:spChg>
-        <pc:spChg chg="del">
-          <ac:chgData name="John Rolzhausen" userId="f0fced98129e348e" providerId="LiveId" clId="{FAB81778-C2AB-48D5-BA9E-3E19BB729E3D}" dt="2025-11-24T17:58:20.160" v="295" actId="478"/>
-          <ac:spMkLst>
-            <pc:docMk/>
-            <pc:sldMk cId="343244891" sldId="261"/>
-            <ac:spMk id="14" creationId="{94B3265D-625F-F6DC-A06E-98603A63CBC2}"/>
-          </ac:spMkLst>
-        </pc:spChg>
         <pc:spChg chg="add mod">
           <ac:chgData name="John Rolzhausen" userId="f0fced98129e348e" providerId="LiveId" clId="{FAB81778-C2AB-48D5-BA9E-3E19BB729E3D}" dt="2025-11-24T18:07:11.211" v="643" actId="1076"/>
           <ac:spMkLst>
@@ -381,44 +232,12 @@
             <ac:spMk id="16" creationId="{E7049CE1-F33B-EF8B-78B7-2C2B06355BC2}"/>
           </ac:spMkLst>
         </pc:spChg>
-        <pc:spChg chg="del mod">
-          <ac:chgData name="John Rolzhausen" userId="f0fced98129e348e" providerId="LiveId" clId="{FAB81778-C2AB-48D5-BA9E-3E19BB729E3D}" dt="2025-11-24T18:06:26.440" v="638" actId="478"/>
-          <ac:spMkLst>
-            <pc:docMk/>
-            <pc:sldMk cId="343244891" sldId="261"/>
-            <ac:spMk id="17" creationId="{E8E66B93-C8D1-3660-0A92-43C5D5F7BD15}"/>
-          </ac:spMkLst>
-        </pc:spChg>
-        <pc:spChg chg="del">
-          <ac:chgData name="John Rolzhausen" userId="f0fced98129e348e" providerId="LiveId" clId="{FAB81778-C2AB-48D5-BA9E-3E19BB729E3D}" dt="2025-11-24T17:59:39.072" v="509" actId="478"/>
-          <ac:spMkLst>
-            <pc:docMk/>
-            <pc:sldMk cId="343244891" sldId="261"/>
-            <ac:spMk id="18" creationId="{F660570C-A68D-9E02-C519-1A58002E29DC}"/>
-          </ac:spMkLst>
-        </pc:spChg>
         <pc:spChg chg="add mod">
           <ac:chgData name="John Rolzhausen" userId="f0fced98129e348e" providerId="LiveId" clId="{FAB81778-C2AB-48D5-BA9E-3E19BB729E3D}" dt="2025-11-24T18:07:19.909" v="645" actId="1076"/>
           <ac:spMkLst>
             <pc:docMk/>
             <pc:sldMk cId="343244891" sldId="261"/>
             <ac:spMk id="19" creationId="{D8372508-5621-45F0-910C-7C7F3B4A7565}"/>
-          </ac:spMkLst>
-        </pc:spChg>
-        <pc:spChg chg="del">
-          <ac:chgData name="John Rolzhausen" userId="f0fced98129e348e" providerId="LiveId" clId="{FAB81778-C2AB-48D5-BA9E-3E19BB729E3D}" dt="2025-11-24T17:59:34.639" v="506" actId="478"/>
-          <ac:spMkLst>
-            <pc:docMk/>
-            <pc:sldMk cId="343244891" sldId="261"/>
-            <ac:spMk id="20" creationId="{9B17A592-994A-6037-5584-96DBCB98349F}"/>
-          </ac:spMkLst>
-        </pc:spChg>
-        <pc:spChg chg="del">
-          <ac:chgData name="John Rolzhausen" userId="f0fced98129e348e" providerId="LiveId" clId="{FAB81778-C2AB-48D5-BA9E-3E19BB729E3D}" dt="2025-11-24T17:59:32.968" v="504" actId="478"/>
-          <ac:spMkLst>
-            <pc:docMk/>
-            <pc:sldMk cId="343244891" sldId="261"/>
-            <ac:spMk id="21" creationId="{2B2B873F-C79B-AA16-6A93-5CDBBDE20210}"/>
           </ac:spMkLst>
         </pc:spChg>
         <pc:spChg chg="add mod">
@@ -454,7 +273,7 @@
           </ac:spMkLst>
         </pc:spChg>
         <pc:spChg chg="add mod">
-          <ac:chgData name="John Rolzhausen" userId="f0fced98129e348e" providerId="LiveId" clId="{FAB81778-C2AB-48D5-BA9E-3E19BB729E3D}" dt="2025-11-24T18:16:03.969" v="700"/>
+          <ac:chgData name="John Rolzhausen" userId="f0fced98129e348e" providerId="LiveId" clId="{FAB81778-C2AB-48D5-BA9E-3E19BB729E3D}" dt="2025-12-15T20:29:27.391" v="3074" actId="6549"/>
           <ac:spMkLst>
             <pc:docMk/>
             <pc:sldMk cId="343244891" sldId="261"/>
@@ -486,188 +305,6 @@
           </ac:spMkLst>
         </pc:spChg>
       </pc:sldChg>
-      <pc:sldChg chg="addSp delSp modSp add del mod">
-        <pc:chgData name="John Rolzhausen" userId="f0fced98129e348e" providerId="LiveId" clId="{FAB81778-C2AB-48D5-BA9E-3E19BB729E3D}" dt="2025-11-24T17:55:21.890" v="120" actId="47"/>
-        <pc:sldMkLst>
-          <pc:docMk/>
-          <pc:sldMk cId="2813193644" sldId="262"/>
-        </pc:sldMkLst>
-        <pc:spChg chg="mod">
-          <ac:chgData name="John Rolzhausen" userId="f0fced98129e348e" providerId="LiveId" clId="{FAB81778-C2AB-48D5-BA9E-3E19BB729E3D}" dt="2025-11-24T17:44:26.898" v="34" actId="27636"/>
-          <ac:spMkLst>
-            <pc:docMk/>
-            <pc:sldMk cId="2813193644" sldId="262"/>
-            <ac:spMk id="2" creationId="{9457F3CD-5A7A-1947-A16F-4B1550C01CDA}"/>
-          </ac:spMkLst>
-        </pc:spChg>
-        <pc:spChg chg="del">
-          <ac:chgData name="John Rolzhausen" userId="f0fced98129e348e" providerId="LiveId" clId="{FAB81778-C2AB-48D5-BA9E-3E19BB729E3D}" dt="2025-11-24T17:44:43.216" v="37" actId="478"/>
-          <ac:spMkLst>
-            <pc:docMk/>
-            <pc:sldMk cId="2813193644" sldId="262"/>
-            <ac:spMk id="4" creationId="{253C5809-9D4F-694C-DF33-2D44B3C0EDE3}"/>
-          </ac:spMkLst>
-        </pc:spChg>
-        <pc:spChg chg="del mod">
-          <ac:chgData name="John Rolzhausen" userId="f0fced98129e348e" providerId="LiveId" clId="{FAB81778-C2AB-48D5-BA9E-3E19BB729E3D}" dt="2025-11-24T17:45:35.328" v="57" actId="478"/>
-          <ac:spMkLst>
-            <pc:docMk/>
-            <pc:sldMk cId="2813193644" sldId="262"/>
-            <ac:spMk id="5" creationId="{4642CA8C-2E79-D2D0-E7B6-E0EED4505E00}"/>
-          </ac:spMkLst>
-        </pc:spChg>
-        <pc:spChg chg="del mod">
-          <ac:chgData name="John Rolzhausen" userId="f0fced98129e348e" providerId="LiveId" clId="{FAB81778-C2AB-48D5-BA9E-3E19BB729E3D}" dt="2025-11-24T17:44:50.208" v="41" actId="478"/>
-          <ac:spMkLst>
-            <pc:docMk/>
-            <pc:sldMk cId="2813193644" sldId="262"/>
-            <ac:spMk id="6" creationId="{5387265F-4FF2-ADB9-5808-789CCDF45807}"/>
-          </ac:spMkLst>
-        </pc:spChg>
-        <pc:spChg chg="del">
-          <ac:chgData name="John Rolzhausen" userId="f0fced98129e348e" providerId="LiveId" clId="{FAB81778-C2AB-48D5-BA9E-3E19BB729E3D}" dt="2025-11-24T17:45:03.551" v="51" actId="478"/>
-          <ac:spMkLst>
-            <pc:docMk/>
-            <pc:sldMk cId="2813193644" sldId="262"/>
-            <ac:spMk id="7" creationId="{96E8F678-64DF-9F70-5A6F-6C43FD46377D}"/>
-          </ac:spMkLst>
-        </pc:spChg>
-        <pc:spChg chg="del">
-          <ac:chgData name="John Rolzhausen" userId="f0fced98129e348e" providerId="LiveId" clId="{FAB81778-C2AB-48D5-BA9E-3E19BB729E3D}" dt="2025-11-24T17:45:05.640" v="53" actId="478"/>
-          <ac:spMkLst>
-            <pc:docMk/>
-            <pc:sldMk cId="2813193644" sldId="262"/>
-            <ac:spMk id="8" creationId="{922D6772-CC16-16F8-5B6E-705331713787}"/>
-          </ac:spMkLst>
-        </pc:spChg>
-        <pc:spChg chg="del">
-          <ac:chgData name="John Rolzhausen" userId="f0fced98129e348e" providerId="LiveId" clId="{FAB81778-C2AB-48D5-BA9E-3E19BB729E3D}" dt="2025-11-24T17:44:39.628" v="35" actId="478"/>
-          <ac:spMkLst>
-            <pc:docMk/>
-            <pc:sldMk cId="2813193644" sldId="262"/>
-            <ac:spMk id="9" creationId="{DF693470-EBB9-656E-25D6-5B6F95F2A512}"/>
-          </ac:spMkLst>
-        </pc:spChg>
-        <pc:spChg chg="del">
-          <ac:chgData name="John Rolzhausen" userId="f0fced98129e348e" providerId="LiveId" clId="{FAB81778-C2AB-48D5-BA9E-3E19BB729E3D}" dt="2025-11-24T17:44:59.071" v="47" actId="478"/>
-          <ac:spMkLst>
-            <pc:docMk/>
-            <pc:sldMk cId="2813193644" sldId="262"/>
-            <ac:spMk id="10" creationId="{60A66F81-4347-324B-F21F-A48C0CFE49D2}"/>
-          </ac:spMkLst>
-        </pc:spChg>
-        <pc:spChg chg="del">
-          <ac:chgData name="John Rolzhausen" userId="f0fced98129e348e" providerId="LiveId" clId="{FAB81778-C2AB-48D5-BA9E-3E19BB729E3D}" dt="2025-11-24T17:44:52.714" v="42" actId="478"/>
-          <ac:spMkLst>
-            <pc:docMk/>
-            <pc:sldMk cId="2813193644" sldId="262"/>
-            <ac:spMk id="11" creationId="{52104BF4-39A3-4CEF-FF55-E4413EEC0CE2}"/>
-          </ac:spMkLst>
-        </pc:spChg>
-        <pc:spChg chg="del">
-          <ac:chgData name="John Rolzhausen" userId="f0fced98129e348e" providerId="LiveId" clId="{FAB81778-C2AB-48D5-BA9E-3E19BB729E3D}" dt="2025-11-24T17:45:01.184" v="49" actId="478"/>
-          <ac:spMkLst>
-            <pc:docMk/>
-            <pc:sldMk cId="2813193644" sldId="262"/>
-            <ac:spMk id="12" creationId="{3B19530F-9502-0C2F-E9F9-8D1EA53D615F}"/>
-          </ac:spMkLst>
-        </pc:spChg>
-        <pc:spChg chg="del mod">
-          <ac:chgData name="John Rolzhausen" userId="f0fced98129e348e" providerId="LiveId" clId="{FAB81778-C2AB-48D5-BA9E-3E19BB729E3D}" dt="2025-11-24T17:45:33.402" v="55" actId="478"/>
-          <ac:spMkLst>
-            <pc:docMk/>
-            <pc:sldMk cId="2813193644" sldId="262"/>
-            <ac:spMk id="13" creationId="{11628F7A-82D4-9510-84D4-CAB06D312551}"/>
-          </ac:spMkLst>
-        </pc:spChg>
-        <pc:spChg chg="del mod">
-          <ac:chgData name="John Rolzhausen" userId="f0fced98129e348e" providerId="LiveId" clId="{FAB81778-C2AB-48D5-BA9E-3E19BB729E3D}" dt="2025-11-24T17:44:57.328" v="46" actId="478"/>
-          <ac:spMkLst>
-            <pc:docMk/>
-            <pc:sldMk cId="2813193644" sldId="262"/>
-            <ac:spMk id="14" creationId="{00EF021B-0758-77FE-108E-5C808B7DAA8D}"/>
-          </ac:spMkLst>
-        </pc:spChg>
-        <pc:spChg chg="add mod">
-          <ac:chgData name="John Rolzhausen" userId="f0fced98129e348e" providerId="LiveId" clId="{FAB81778-C2AB-48D5-BA9E-3E19BB729E3D}" dt="2025-11-24T17:51:17.077" v="87" actId="6549"/>
-          <ac:spMkLst>
-            <pc:docMk/>
-            <pc:sldMk cId="2813193644" sldId="262"/>
-            <ac:spMk id="15" creationId="{B9B8C798-2358-2B75-6310-189D277E41BD}"/>
-          </ac:spMkLst>
-        </pc:spChg>
-        <pc:spChg chg="add del mod">
-          <ac:chgData name="John Rolzhausen" userId="f0fced98129e348e" providerId="LiveId" clId="{FAB81778-C2AB-48D5-BA9E-3E19BB729E3D}" dt="2025-11-24T17:48:24.417" v="69" actId="478"/>
-          <ac:spMkLst>
-            <pc:docMk/>
-            <pc:sldMk cId="2813193644" sldId="262"/>
-            <ac:spMk id="16" creationId="{A8B1B461-439A-4E36-D660-1B43F0BD10FD}"/>
-          </ac:spMkLst>
-        </pc:spChg>
-        <pc:spChg chg="del mod">
-          <ac:chgData name="John Rolzhausen" userId="f0fced98129e348e" providerId="LiveId" clId="{FAB81778-C2AB-48D5-BA9E-3E19BB729E3D}" dt="2025-11-24T17:44:55.177" v="44" actId="478"/>
-          <ac:spMkLst>
-            <pc:docMk/>
-            <pc:sldMk cId="2813193644" sldId="262"/>
-            <ac:spMk id="17" creationId="{74647C59-F67A-69FA-C821-5DA3C7FB1A89}"/>
-          </ac:spMkLst>
-        </pc:spChg>
-        <pc:spChg chg="del">
-          <ac:chgData name="John Rolzhausen" userId="f0fced98129e348e" providerId="LiveId" clId="{FAB81778-C2AB-48D5-BA9E-3E19BB729E3D}" dt="2025-11-24T17:44:41.416" v="36" actId="478"/>
-          <ac:spMkLst>
-            <pc:docMk/>
-            <pc:sldMk cId="2813193644" sldId="262"/>
-            <ac:spMk id="18" creationId="{34002F74-E9A2-4687-7FEA-F83A4ECE4CB3}"/>
-          </ac:spMkLst>
-        </pc:spChg>
-        <pc:spChg chg="add del mod">
-          <ac:chgData name="John Rolzhausen" userId="f0fced98129e348e" providerId="LiveId" clId="{FAB81778-C2AB-48D5-BA9E-3E19BB729E3D}" dt="2025-11-24T17:49:20.009" v="76" actId="478"/>
-          <ac:spMkLst>
-            <pc:docMk/>
-            <pc:sldMk cId="2813193644" sldId="262"/>
-            <ac:spMk id="19" creationId="{25FC41D2-8E2D-4B8B-962A-21732CCA6176}"/>
-          </ac:spMkLst>
-        </pc:spChg>
-        <pc:spChg chg="del">
-          <ac:chgData name="John Rolzhausen" userId="f0fced98129e348e" providerId="LiveId" clId="{FAB81778-C2AB-48D5-BA9E-3E19BB729E3D}" dt="2025-11-24T17:45:00.431" v="48" actId="478"/>
-          <ac:spMkLst>
-            <pc:docMk/>
-            <pc:sldMk cId="2813193644" sldId="262"/>
-            <ac:spMk id="20" creationId="{F268B8FE-F876-D449-7645-A3FBEA0EA030}"/>
-          </ac:spMkLst>
-        </pc:spChg>
-        <pc:spChg chg="del mod">
-          <ac:chgData name="John Rolzhausen" userId="f0fced98129e348e" providerId="LiveId" clId="{FAB81778-C2AB-48D5-BA9E-3E19BB729E3D}" dt="2025-11-24T17:45:04.176" v="52" actId="478"/>
-          <ac:spMkLst>
-            <pc:docMk/>
-            <pc:sldMk cId="2813193644" sldId="262"/>
-            <ac:spMk id="21" creationId="{6078BCF1-FA4B-309F-B5C4-E4084A4D0B50}"/>
-          </ac:spMkLst>
-        </pc:spChg>
-        <pc:spChg chg="add mod">
-          <ac:chgData name="John Rolzhausen" userId="f0fced98129e348e" providerId="LiveId" clId="{FAB81778-C2AB-48D5-BA9E-3E19BB729E3D}" dt="2025-11-24T17:51:25.449" v="88" actId="1076"/>
-          <ac:spMkLst>
-            <pc:docMk/>
-            <pc:sldMk cId="2813193644" sldId="262"/>
-            <ac:spMk id="22" creationId="{4EDB53EA-D78D-41CC-EF62-D5333386BA34}"/>
-          </ac:spMkLst>
-        </pc:spChg>
-        <pc:spChg chg="add mod">
-          <ac:chgData name="John Rolzhausen" userId="f0fced98129e348e" providerId="LiveId" clId="{FAB81778-C2AB-48D5-BA9E-3E19BB729E3D}" dt="2025-11-24T17:50:18.547" v="84" actId="6549"/>
-          <ac:spMkLst>
-            <pc:docMk/>
-            <pc:sldMk cId="2813193644" sldId="262"/>
-            <ac:spMk id="23" creationId="{6512EF11-3E15-CB10-8AC2-E9A10285EEE0}"/>
-          </ac:spMkLst>
-        </pc:spChg>
-      </pc:sldChg>
-      <pc:sldChg chg="new del">
-        <pc:chgData name="John Rolzhausen" userId="f0fced98129e348e" providerId="LiveId" clId="{FAB81778-C2AB-48D5-BA9E-3E19BB729E3D}" dt="2025-11-24T17:36:38.546" v="13" actId="47"/>
-        <pc:sldMkLst>
-          <pc:docMk/>
-          <pc:sldMk cId="3878684774" sldId="262"/>
-        </pc:sldMkLst>
-      </pc:sldChg>
       <pc:sldChg chg="addSp delSp modSp add mod ord">
         <pc:chgData name="John Rolzhausen" userId="f0fced98129e348e" providerId="LiveId" clId="{FAB81778-C2AB-48D5-BA9E-3E19BB729E3D}" dt="2025-11-24T19:45:42.769" v="1483"/>
         <pc:sldMkLst>
@@ -680,22 +317,6 @@
             <pc:docMk/>
             <pc:sldMk cId="2475428312" sldId="263"/>
             <ac:spMk id="2" creationId="{CED8233C-16F7-3326-258E-7CA97ADDD01F}"/>
-          </ac:spMkLst>
-        </pc:spChg>
-        <pc:spChg chg="del">
-          <ac:chgData name="John Rolzhausen" userId="f0fced98129e348e" providerId="LiveId" clId="{FAB81778-C2AB-48D5-BA9E-3E19BB729E3D}" dt="2025-11-24T17:52:12.860" v="96" actId="478"/>
-          <ac:spMkLst>
-            <pc:docMk/>
-            <pc:sldMk cId="2475428312" sldId="263"/>
-            <ac:spMk id="3" creationId="{F706B2CB-B98E-241D-1824-462651917BCA}"/>
-          </ac:spMkLst>
-        </pc:spChg>
-        <pc:spChg chg="add del mod">
-          <ac:chgData name="John Rolzhausen" userId="f0fced98129e348e" providerId="LiveId" clId="{FAB81778-C2AB-48D5-BA9E-3E19BB729E3D}" dt="2025-11-24T17:52:18.577" v="97" actId="478"/>
-          <ac:spMkLst>
-            <pc:docMk/>
-            <pc:sldMk cId="2475428312" sldId="263"/>
-            <ac:spMk id="5" creationId="{DE9EB617-E65F-EDFD-B865-CB0181D05A27}"/>
           </ac:spMkLst>
         </pc:spChg>
         <pc:spChg chg="add mod">
@@ -722,29 +343,6 @@
             <ac:spMk id="15" creationId="{2478689C-3B96-26E3-A86A-92AF019D2AE3}"/>
           </ac:spMkLst>
         </pc:spChg>
-        <pc:spChg chg="del mod">
-          <ac:chgData name="John Rolzhausen" userId="f0fced98129e348e" providerId="LiveId" clId="{FAB81778-C2AB-48D5-BA9E-3E19BB729E3D}" dt="2025-11-24T17:53:12.031" v="103" actId="478"/>
-          <ac:spMkLst>
-            <pc:docMk/>
-            <pc:sldMk cId="2475428312" sldId="263"/>
-            <ac:spMk id="22" creationId="{7A845B09-F866-6DD4-07B6-F5D9B2AF2DBA}"/>
-          </ac:spMkLst>
-        </pc:spChg>
-        <pc:spChg chg="del mod">
-          <ac:chgData name="John Rolzhausen" userId="f0fced98129e348e" providerId="LiveId" clId="{FAB81778-C2AB-48D5-BA9E-3E19BB729E3D}" dt="2025-11-24T17:53:14.456" v="104" actId="478"/>
-          <ac:spMkLst>
-            <pc:docMk/>
-            <pc:sldMk cId="2475428312" sldId="263"/>
-            <ac:spMk id="23" creationId="{1827D825-8C28-E791-CF3B-967F0491DB49}"/>
-          </ac:spMkLst>
-        </pc:spChg>
-      </pc:sldChg>
-      <pc:sldChg chg="add del">
-        <pc:chgData name="John Rolzhausen" userId="f0fced98129e348e" providerId="LiveId" clId="{FAB81778-C2AB-48D5-BA9E-3E19BB729E3D}" dt="2025-11-24T17:56:45.561" v="128" actId="47"/>
-        <pc:sldMkLst>
-          <pc:docMk/>
-          <pc:sldMk cId="553048967" sldId="264"/>
-        </pc:sldMkLst>
       </pc:sldChg>
       <pc:sldChg chg="addSp delSp modSp add mod ord">
         <pc:chgData name="John Rolzhausen" userId="f0fced98129e348e" providerId="LiveId" clId="{FAB81778-C2AB-48D5-BA9E-3E19BB729E3D}" dt="2025-11-24T19:43:30.540" v="1482" actId="14100"/>
@@ -776,36 +374,12 @@
             <ac:spMk id="4" creationId="{B2C2F119-84BA-725E-7A62-70E19321929E}"/>
           </ac:spMkLst>
         </pc:spChg>
-        <pc:spChg chg="add del mod">
-          <ac:chgData name="John Rolzhausen" userId="f0fced98129e348e" providerId="LiveId" clId="{FAB81778-C2AB-48D5-BA9E-3E19BB729E3D}" dt="2025-11-24T18:33:44.840" v="784" actId="478"/>
-          <ac:spMkLst>
-            <pc:docMk/>
-            <pc:sldMk cId="2138627487" sldId="264"/>
-            <ac:spMk id="5" creationId="{7DAA31BC-C7BE-EE9C-14E4-4A8508458A71}"/>
-          </ac:spMkLst>
-        </pc:spChg>
-        <pc:spChg chg="add del mod">
-          <ac:chgData name="John Rolzhausen" userId="f0fced98129e348e" providerId="LiveId" clId="{FAB81778-C2AB-48D5-BA9E-3E19BB729E3D}" dt="2025-11-24T18:36:58.942" v="841"/>
-          <ac:spMkLst>
-            <pc:docMk/>
-            <pc:sldMk cId="2138627487" sldId="264"/>
-            <ac:spMk id="6" creationId="{BC64DA48-5046-C52B-9141-8BAB0B74F9F4}"/>
-          </ac:spMkLst>
-        </pc:spChg>
         <pc:spChg chg="add mod">
           <ac:chgData name="John Rolzhausen" userId="f0fced98129e348e" providerId="LiveId" clId="{FAB81778-C2AB-48D5-BA9E-3E19BB729E3D}" dt="2025-11-24T18:57:06.315" v="1290" actId="14100"/>
           <ac:spMkLst>
             <pc:docMk/>
             <pc:sldMk cId="2138627487" sldId="264"/>
             <ac:spMk id="7" creationId="{CC1879A4-490F-51E7-DDA5-52A43AFA03A2}"/>
-          </ac:spMkLst>
-        </pc:spChg>
-        <pc:spChg chg="del">
-          <ac:chgData name="John Rolzhausen" userId="f0fced98129e348e" providerId="LiveId" clId="{FAB81778-C2AB-48D5-BA9E-3E19BB729E3D}" dt="2025-11-24T18:32:26.064" v="775" actId="478"/>
-          <ac:spMkLst>
-            <pc:docMk/>
-            <pc:sldMk cId="2138627487" sldId="264"/>
-            <ac:spMk id="9" creationId="{CB984669-817D-B47D-93BC-3D31B85FEE84}"/>
           </ac:spMkLst>
         </pc:spChg>
         <pc:spChg chg="mod">
@@ -825,43 +399,11 @@
           </ac:spMkLst>
         </pc:spChg>
         <pc:spChg chg="add mod">
-          <ac:chgData name="John Rolzhausen" userId="f0fced98129e348e" providerId="LiveId" clId="{FAB81778-C2AB-48D5-BA9E-3E19BB729E3D}" dt="2025-11-24T18:43:06.535" v="976" actId="571"/>
-          <ac:spMkLst>
-            <pc:docMk/>
-            <pc:sldMk cId="2138627487" sldId="264"/>
-            <ac:spMk id="12" creationId="{F9EBAE97-CAD2-3DF6-26CD-B0FA6A461527}"/>
-          </ac:spMkLst>
-        </pc:spChg>
-        <pc:spChg chg="add del mod">
-          <ac:chgData name="John Rolzhausen" userId="f0fced98129e348e" providerId="LiveId" clId="{FAB81778-C2AB-48D5-BA9E-3E19BB729E3D}" dt="2025-11-24T18:54:29.198" v="1244" actId="478"/>
-          <ac:spMkLst>
-            <pc:docMk/>
-            <pc:sldMk cId="2138627487" sldId="264"/>
-            <ac:spMk id="13" creationId="{82D05F11-9344-0BA6-D078-B54262DDA111}"/>
-          </ac:spMkLst>
-        </pc:spChg>
-        <pc:spChg chg="add mod">
           <ac:chgData name="John Rolzhausen" userId="f0fced98129e348e" providerId="LiveId" clId="{FAB81778-C2AB-48D5-BA9E-3E19BB729E3D}" dt="2025-11-24T19:34:24.295" v="1299" actId="14100"/>
           <ac:spMkLst>
             <pc:docMk/>
             <pc:sldMk cId="2138627487" sldId="264"/>
             <ac:spMk id="14" creationId="{FF59BF29-BE9D-1EB9-F96A-3DDA2FACD374}"/>
-          </ac:spMkLst>
-        </pc:spChg>
-        <pc:spChg chg="del">
-          <ac:chgData name="John Rolzhausen" userId="f0fced98129e348e" providerId="LiveId" clId="{FAB81778-C2AB-48D5-BA9E-3E19BB729E3D}" dt="2025-11-24T18:23:53.543" v="729" actId="478"/>
-          <ac:spMkLst>
-            <pc:docMk/>
-            <pc:sldMk cId="2138627487" sldId="264"/>
-            <ac:spMk id="15" creationId="{6A843735-C2A5-83BD-C5C4-E59CF95011FE}"/>
-          </ac:spMkLst>
-        </pc:spChg>
-        <pc:spChg chg="del">
-          <ac:chgData name="John Rolzhausen" userId="f0fced98129e348e" providerId="LiveId" clId="{FAB81778-C2AB-48D5-BA9E-3E19BB729E3D}" dt="2025-11-24T18:23:54.191" v="730" actId="478"/>
-          <ac:spMkLst>
-            <pc:docMk/>
-            <pc:sldMk cId="2138627487" sldId="264"/>
-            <ac:spMk id="16" creationId="{ED1A2A8F-CC56-9476-DE42-48E32F5D7C79}"/>
           </ac:spMkLst>
         </pc:spChg>
         <pc:spChg chg="add mod">
@@ -880,14 +422,6 @@
             <ac:spMk id="18" creationId="{572FA2C2-019F-8E51-65C4-F6E81F8F9889}"/>
           </ac:spMkLst>
         </pc:spChg>
-        <pc:spChg chg="del mod">
-          <ac:chgData name="John Rolzhausen" userId="f0fced98129e348e" providerId="LiveId" clId="{FAB81778-C2AB-48D5-BA9E-3E19BB729E3D}" dt="2025-11-24T18:23:57.548" v="733" actId="478"/>
-          <ac:spMkLst>
-            <pc:docMk/>
-            <pc:sldMk cId="2138627487" sldId="264"/>
-            <ac:spMk id="19" creationId="{F5C6D6D6-9186-2CAA-9895-1AE946155017}"/>
-          </ac:spMkLst>
-        </pc:spChg>
         <pc:spChg chg="add mod">
           <ac:chgData name="John Rolzhausen" userId="f0fced98129e348e" providerId="LiveId" clId="{FAB81778-C2AB-48D5-BA9E-3E19BB729E3D}" dt="2025-11-24T19:42:44.169" v="1474" actId="207"/>
           <ac:spMkLst>
@@ -904,22 +438,6 @@
             <ac:spMk id="21" creationId="{0AF5FFE1-83DB-5702-6384-2A10AD4CF3E1}"/>
           </ac:spMkLst>
         </pc:spChg>
-        <pc:spChg chg="del mod">
-          <ac:chgData name="John Rolzhausen" userId="f0fced98129e348e" providerId="LiveId" clId="{FAB81778-C2AB-48D5-BA9E-3E19BB729E3D}" dt="2025-11-24T18:23:58.481" v="734" actId="478"/>
-          <ac:spMkLst>
-            <pc:docMk/>
-            <pc:sldMk cId="2138627487" sldId="264"/>
-            <ac:spMk id="22" creationId="{AD058D86-E319-E1C4-9045-856A401DF06B}"/>
-          </ac:spMkLst>
-        </pc:spChg>
-        <pc:spChg chg="del mod">
-          <ac:chgData name="John Rolzhausen" userId="f0fced98129e348e" providerId="LiveId" clId="{FAB81778-C2AB-48D5-BA9E-3E19BB729E3D}" dt="2025-11-24T18:24:10.711" v="736" actId="478"/>
-          <ac:spMkLst>
-            <pc:docMk/>
-            <pc:sldMk cId="2138627487" sldId="264"/>
-            <ac:spMk id="23" creationId="{6AF698CD-3CDA-34BF-7C33-94DCF9089C8E}"/>
-          </ac:spMkLst>
-        </pc:spChg>
         <pc:spChg chg="mod">
           <ac:chgData name="John Rolzhausen" userId="f0fced98129e348e" providerId="LiveId" clId="{FAB81778-C2AB-48D5-BA9E-3E19BB729E3D}" dt="2025-11-24T18:29:59.594" v="753" actId="1076"/>
           <ac:spMkLst>
@@ -928,76 +446,12 @@
             <ac:spMk id="24" creationId="{1304F940-26DD-DD49-FBD7-A7329CBD4035}"/>
           </ac:spMkLst>
         </pc:spChg>
-        <pc:spChg chg="del mod">
-          <ac:chgData name="John Rolzhausen" userId="f0fced98129e348e" providerId="LiveId" clId="{FAB81778-C2AB-48D5-BA9E-3E19BB729E3D}" dt="2025-11-24T18:32:30.358" v="776" actId="478"/>
-          <ac:spMkLst>
-            <pc:docMk/>
-            <pc:sldMk cId="2138627487" sldId="264"/>
-            <ac:spMk id="25" creationId="{AE7EF488-DF9E-367C-FAD4-521129DB1D27}"/>
-          </ac:spMkLst>
-        </pc:spChg>
-        <pc:spChg chg="del mod">
-          <ac:chgData name="John Rolzhausen" userId="f0fced98129e348e" providerId="LiveId" clId="{FAB81778-C2AB-48D5-BA9E-3E19BB729E3D}" dt="2025-11-24T18:32:33.896" v="778" actId="478"/>
-          <ac:spMkLst>
-            <pc:docMk/>
-            <pc:sldMk cId="2138627487" sldId="264"/>
-            <ac:spMk id="26" creationId="{7E1F5ABE-B17B-7A7F-CF74-454D3D3010A3}"/>
-          </ac:spMkLst>
-        </pc:spChg>
-        <pc:spChg chg="del">
-          <ac:chgData name="John Rolzhausen" userId="f0fced98129e348e" providerId="LiveId" clId="{FAB81778-C2AB-48D5-BA9E-3E19BB729E3D}" dt="2025-11-24T18:42:59.810" v="974" actId="21"/>
-          <ac:spMkLst>
-            <pc:docMk/>
-            <pc:sldMk cId="2138627487" sldId="264"/>
-            <ac:spMk id="27" creationId="{C1ECFC68-54FD-7438-F084-55A55DE8AFC9}"/>
-          </ac:spMkLst>
-        </pc:spChg>
-        <pc:spChg chg="del">
-          <ac:chgData name="John Rolzhausen" userId="f0fced98129e348e" providerId="LiveId" clId="{FAB81778-C2AB-48D5-BA9E-3E19BB729E3D}" dt="2025-11-24T18:42:59.810" v="974" actId="21"/>
-          <ac:spMkLst>
-            <pc:docMk/>
-            <pc:sldMk cId="2138627487" sldId="264"/>
-            <ac:spMk id="28" creationId="{99279F58-AFB7-31AE-8A3C-C18E484B74B1}"/>
-          </ac:spMkLst>
-        </pc:spChg>
-        <pc:spChg chg="del">
-          <ac:chgData name="John Rolzhausen" userId="f0fced98129e348e" providerId="LiveId" clId="{FAB81778-C2AB-48D5-BA9E-3E19BB729E3D}" dt="2025-11-24T18:42:59.810" v="974" actId="21"/>
-          <ac:spMkLst>
-            <pc:docMk/>
-            <pc:sldMk cId="2138627487" sldId="264"/>
-            <ac:spMk id="29" creationId="{5BAFAAF8-6223-0253-44CA-922362528D69}"/>
-          </ac:spMkLst>
-        </pc:spChg>
         <pc:spChg chg="add mod">
           <ac:chgData name="John Rolzhausen" userId="f0fced98129e348e" providerId="LiveId" clId="{FAB81778-C2AB-48D5-BA9E-3E19BB729E3D}" dt="2025-11-24T19:42:32.065" v="1472" actId="207"/>
           <ac:spMkLst>
             <pc:docMk/>
             <pc:sldMk cId="2138627487" sldId="264"/>
             <ac:spMk id="30" creationId="{7BCCEB63-E92F-8212-B75B-9B6BC685048F}"/>
-          </ac:spMkLst>
-        </pc:spChg>
-        <pc:spChg chg="add del mod">
-          <ac:chgData name="John Rolzhausen" userId="f0fced98129e348e" providerId="LiveId" clId="{FAB81778-C2AB-48D5-BA9E-3E19BB729E3D}" dt="2025-11-24T19:38:57.495" v="1379" actId="478"/>
-          <ac:spMkLst>
-            <pc:docMk/>
-            <pc:sldMk cId="2138627487" sldId="264"/>
-            <ac:spMk id="31" creationId="{34161653-F38B-A085-427B-88E2E14A5BBE}"/>
-          </ac:spMkLst>
-        </pc:spChg>
-        <pc:spChg chg="add del mod">
-          <ac:chgData name="John Rolzhausen" userId="f0fced98129e348e" providerId="LiveId" clId="{FAB81778-C2AB-48D5-BA9E-3E19BB729E3D}" dt="2025-11-24T19:38:57.495" v="1379" actId="478"/>
-          <ac:spMkLst>
-            <pc:docMk/>
-            <pc:sldMk cId="2138627487" sldId="264"/>
-            <ac:spMk id="32" creationId="{3FE218C2-4303-81E1-3F84-34682393D632}"/>
-          </ac:spMkLst>
-        </pc:spChg>
-        <pc:spChg chg="add del mod">
-          <ac:chgData name="John Rolzhausen" userId="f0fced98129e348e" providerId="LiveId" clId="{FAB81778-C2AB-48D5-BA9E-3E19BB729E3D}" dt="2025-11-24T19:38:57.495" v="1379" actId="478"/>
-          <ac:spMkLst>
-            <pc:docMk/>
-            <pc:sldMk cId="2138627487" sldId="264"/>
-            <ac:spMk id="33" creationId="{68E6C044-D6D1-0A0D-2C48-674568E46A8D}"/>
           </ac:spMkLst>
         </pc:spChg>
         <pc:spChg chg="add mod">
@@ -1017,27 +471,44 @@
           </ac:spMkLst>
         </pc:spChg>
       </pc:sldChg>
-      <pc:sldChg chg="modSp add ord">
-        <pc:chgData name="John Rolzhausen" userId="f0fced98129e348e" providerId="LiveId" clId="{FAB81778-C2AB-48D5-BA9E-3E19BB729E3D}" dt="2025-11-24T18:30:07.405" v="760"/>
+      <pc:sldChg chg="modSp add mod ord">
+        <pc:chgData name="John Rolzhausen" userId="f0fced98129e348e" providerId="LiveId" clId="{FAB81778-C2AB-48D5-BA9E-3E19BB729E3D}" dt="2025-12-15T21:31:38.931" v="3076" actId="6549"/>
         <pc:sldMkLst>
           <pc:docMk/>
           <pc:sldMk cId="552849500" sldId="265"/>
         </pc:sldMkLst>
         <pc:spChg chg="mod">
-          <ac:chgData name="John Rolzhausen" userId="f0fced98129e348e" providerId="LiveId" clId="{FAB81778-C2AB-48D5-BA9E-3E19BB729E3D}" dt="2025-11-24T18:30:00.703" v="755"/>
+          <ac:chgData name="John Rolzhausen" userId="f0fced98129e348e" providerId="LiveId" clId="{FAB81778-C2AB-48D5-BA9E-3E19BB729E3D}" dt="2025-12-14T01:55:59.862" v="3071" actId="20577"/>
+          <ac:spMkLst>
+            <pc:docMk/>
+            <pc:sldMk cId="552849500" sldId="265"/>
+            <ac:spMk id="2" creationId="{BB63C44D-230C-B9FA-0CD2-7B5DE8C31032}"/>
+          </ac:spMkLst>
+        </pc:spChg>
+        <pc:spChg chg="mod">
+          <ac:chgData name="John Rolzhausen" userId="f0fced98129e348e" providerId="LiveId" clId="{FAB81778-C2AB-48D5-BA9E-3E19BB729E3D}" dt="2025-12-14T01:56:14.777" v="3072" actId="20577"/>
+          <ac:spMkLst>
+            <pc:docMk/>
+            <pc:sldMk cId="552849500" sldId="265"/>
+            <ac:spMk id="6" creationId="{51AEFDCA-DF23-6D97-BC93-5DA9496185D9}"/>
+          </ac:spMkLst>
+        </pc:spChg>
+        <pc:spChg chg="mod">
+          <ac:chgData name="John Rolzhausen" userId="f0fced98129e348e" providerId="LiveId" clId="{FAB81778-C2AB-48D5-BA9E-3E19BB729E3D}" dt="2025-12-15T21:31:38.931" v="3076" actId="6549"/>
+          <ac:spMkLst>
+            <pc:docMk/>
+            <pc:sldMk cId="552849500" sldId="265"/>
+            <ac:spMk id="7" creationId="{40CFB9FF-E8C0-B4DA-F6BB-64E9D5FBC707}"/>
+          </ac:spMkLst>
+        </pc:spChg>
+        <pc:spChg chg="mod">
+          <ac:chgData name="John Rolzhausen" userId="f0fced98129e348e" providerId="LiveId" clId="{FAB81778-C2AB-48D5-BA9E-3E19BB729E3D}" dt="2025-12-14T01:54:54.353" v="3069" actId="6549"/>
           <ac:spMkLst>
             <pc:docMk/>
             <pc:sldMk cId="552849500" sldId="265"/>
             <ac:spMk id="15" creationId="{6A7538DD-9580-A6E8-B2B3-533A1151D60A}"/>
           </ac:spMkLst>
         </pc:spChg>
-      </pc:sldChg>
-      <pc:sldChg chg="add del">
-        <pc:chgData name="John Rolzhausen" userId="f0fced98129e348e" providerId="LiveId" clId="{FAB81778-C2AB-48D5-BA9E-3E19BB729E3D}" dt="2025-11-24T18:29:53.232" v="746" actId="2890"/>
-        <pc:sldMkLst>
-          <pc:docMk/>
-          <pc:sldMk cId="2108268007" sldId="266"/>
-        </pc:sldMkLst>
       </pc:sldChg>
       <pc:sldChg chg="delSp modSp add mod">
         <pc:chgData name="John Rolzhausen" userId="f0fced98129e348e" providerId="LiveId" clId="{FAB81778-C2AB-48D5-BA9E-3E19BB729E3D}" dt="2025-11-24T19:45:51.533" v="1488" actId="20577"/>
@@ -1059,14 +530,6 @@
             <pc:docMk/>
             <pc:sldMk cId="2972217979" sldId="266"/>
             <ac:spMk id="6" creationId="{00CDA56A-EC5F-FFE3-4862-B1A193580CA2}"/>
-          </ac:spMkLst>
-        </pc:spChg>
-        <pc:spChg chg="del mod">
-          <ac:chgData name="John Rolzhausen" userId="f0fced98129e348e" providerId="LiveId" clId="{FAB81778-C2AB-48D5-BA9E-3E19BB729E3D}" dt="2025-11-24T18:31:03.985" v="768" actId="478"/>
-          <ac:spMkLst>
-            <pc:docMk/>
-            <pc:sldMk cId="2972217979" sldId="266"/>
-            <ac:spMk id="7" creationId="{883CBCCA-6FA9-A02D-58B4-BF8E2A80A8B5}"/>
           </ac:spMkLst>
         </pc:spChg>
         <pc:spChg chg="mod">
@@ -1179,78 +642,6 @@
             <ac:spMk id="9" creationId="{8C97591C-9864-8571-FF01-1ED83225DB5E}"/>
           </ac:spMkLst>
         </pc:spChg>
-        <pc:spChg chg="del">
-          <ac:chgData name="John Rolzhausen" userId="f0fced98129e348e" providerId="LiveId" clId="{FAB81778-C2AB-48D5-BA9E-3E19BB729E3D}" dt="2025-11-24T19:52:24.960" v="1514" actId="478"/>
-          <ac:spMkLst>
-            <pc:docMk/>
-            <pc:sldMk cId="3202500457" sldId="268"/>
-            <ac:spMk id="10" creationId="{5D943AA5-DDC8-ABD1-1D5A-5EA7E9F63B16}"/>
-          </ac:spMkLst>
-        </pc:spChg>
-        <pc:spChg chg="del">
-          <ac:chgData name="John Rolzhausen" userId="f0fced98129e348e" providerId="LiveId" clId="{FAB81778-C2AB-48D5-BA9E-3E19BB729E3D}" dt="2025-11-24T19:52:12.365" v="1509" actId="478"/>
-          <ac:spMkLst>
-            <pc:docMk/>
-            <pc:sldMk cId="3202500457" sldId="268"/>
-            <ac:spMk id="15" creationId="{2D551737-1D05-4966-4A23-4F339497C2B0}"/>
-          </ac:spMkLst>
-        </pc:spChg>
-        <pc:spChg chg="del">
-          <ac:chgData name="John Rolzhausen" userId="f0fced98129e348e" providerId="LiveId" clId="{FAB81778-C2AB-48D5-BA9E-3E19BB729E3D}" dt="2025-11-24T19:52:14.060" v="1510" actId="478"/>
-          <ac:spMkLst>
-            <pc:docMk/>
-            <pc:sldMk cId="3202500457" sldId="268"/>
-            <ac:spMk id="16" creationId="{F8A37C11-DAC6-CAAB-73ED-5A6AF920A859}"/>
-          </ac:spMkLst>
-        </pc:spChg>
-        <pc:spChg chg="del mod">
-          <ac:chgData name="John Rolzhausen" userId="f0fced98129e348e" providerId="LiveId" clId="{FAB81778-C2AB-48D5-BA9E-3E19BB729E3D}" dt="2025-11-24T19:52:16.285" v="1512" actId="478"/>
-          <ac:spMkLst>
-            <pc:docMk/>
-            <pc:sldMk cId="3202500457" sldId="268"/>
-            <ac:spMk id="19" creationId="{2C3643EA-9F20-FB38-72E3-E28BBB1CA603}"/>
-          </ac:spMkLst>
-        </pc:spChg>
-        <pc:spChg chg="del">
-          <ac:chgData name="John Rolzhausen" userId="f0fced98129e348e" providerId="LiveId" clId="{FAB81778-C2AB-48D5-BA9E-3E19BB729E3D}" dt="2025-11-24T19:52:17.154" v="1513" actId="478"/>
-          <ac:spMkLst>
-            <pc:docMk/>
-            <pc:sldMk cId="3202500457" sldId="268"/>
-            <ac:spMk id="22" creationId="{2AA440BF-5BF9-D052-DD8D-6AF6A7F099DD}"/>
-          </ac:spMkLst>
-        </pc:spChg>
-        <pc:spChg chg="del mod">
-          <ac:chgData name="John Rolzhausen" userId="f0fced98129e348e" providerId="LiveId" clId="{FAB81778-C2AB-48D5-BA9E-3E19BB729E3D}" dt="2025-11-24T19:54:50.349" v="1526" actId="478"/>
-          <ac:spMkLst>
-            <pc:docMk/>
-            <pc:sldMk cId="3202500457" sldId="268"/>
-            <ac:spMk id="23" creationId="{DB0A201A-8B0C-3C56-EBE2-EF06CA2B4E11}"/>
-          </ac:spMkLst>
-        </pc:spChg>
-        <pc:spChg chg="del mod">
-          <ac:chgData name="John Rolzhausen" userId="f0fced98129e348e" providerId="LiveId" clId="{FAB81778-C2AB-48D5-BA9E-3E19BB729E3D}" dt="2025-11-24T19:55:00.948" v="1532" actId="478"/>
-          <ac:spMkLst>
-            <pc:docMk/>
-            <pc:sldMk cId="3202500457" sldId="268"/>
-            <ac:spMk id="24" creationId="{73877B72-A702-1E4A-0828-E9BE5DBC36E6}"/>
-          </ac:spMkLst>
-        </pc:spChg>
-        <pc:spChg chg="del">
-          <ac:chgData name="John Rolzhausen" userId="f0fced98129e348e" providerId="LiveId" clId="{FAB81778-C2AB-48D5-BA9E-3E19BB729E3D}" dt="2025-11-24T19:55:03.614" v="1533" actId="478"/>
-          <ac:spMkLst>
-            <pc:docMk/>
-            <pc:sldMk cId="3202500457" sldId="268"/>
-            <ac:spMk id="25" creationId="{D7B0A109-62ED-F0D1-FB49-4CFBE35DA534}"/>
-          </ac:spMkLst>
-        </pc:spChg>
-        <pc:spChg chg="del mod">
-          <ac:chgData name="John Rolzhausen" userId="f0fced98129e348e" providerId="LiveId" clId="{FAB81778-C2AB-48D5-BA9E-3E19BB729E3D}" dt="2025-11-24T19:55:06.908" v="1535" actId="478"/>
-          <ac:spMkLst>
-            <pc:docMk/>
-            <pc:sldMk cId="3202500457" sldId="268"/>
-            <ac:spMk id="26" creationId="{FD853BEF-ABE1-D63C-17DE-D3A156B781BD}"/>
-          </ac:spMkLst>
-        </pc:spChg>
         <pc:spChg chg="mod">
           <ac:chgData name="John Rolzhausen" userId="f0fced98129e348e" providerId="LiveId" clId="{FAB81778-C2AB-48D5-BA9E-3E19BB729E3D}" dt="2025-11-24T20:31:33.395" v="2253" actId="20577"/>
           <ac:spMkLst>
@@ -1353,36 +744,12 @@
             <ac:spMk id="5" creationId="{64595316-0CEF-6E07-FDE2-3134DBBBCB27}"/>
           </ac:spMkLst>
         </pc:spChg>
-        <pc:spChg chg="del mod">
-          <ac:chgData name="John Rolzhausen" userId="f0fced98129e348e" providerId="LiveId" clId="{FAB81778-C2AB-48D5-BA9E-3E19BB729E3D}" dt="2025-11-24T21:24:12.673" v="2356" actId="478"/>
-          <ac:spMkLst>
-            <pc:docMk/>
-            <pc:sldMk cId="1376577602" sldId="270"/>
-            <ac:spMk id="7" creationId="{C20BE404-F5CA-99F1-FB41-3BC47A5F8E80}"/>
-          </ac:spMkLst>
-        </pc:spChg>
-        <pc:spChg chg="add del">
-          <ac:chgData name="John Rolzhausen" userId="f0fced98129e348e" providerId="LiveId" clId="{FAB81778-C2AB-48D5-BA9E-3E19BB729E3D}" dt="2025-11-24T21:33:40.839" v="2429" actId="22"/>
-          <ac:spMkLst>
-            <pc:docMk/>
-            <pc:sldMk cId="1376577602" sldId="270"/>
-            <ac:spMk id="9" creationId="{3C8CF4D2-3999-C5EF-8379-2D065EC1F93F}"/>
-          </ac:spMkLst>
-        </pc:spChg>
         <pc:spChg chg="mod">
           <ac:chgData name="John Rolzhausen" userId="f0fced98129e348e" providerId="LiveId" clId="{FAB81778-C2AB-48D5-BA9E-3E19BB729E3D}" dt="2025-11-24T21:23:05.558" v="2346" actId="113"/>
           <ac:spMkLst>
             <pc:docMk/>
             <pc:sldMk cId="1376577602" sldId="270"/>
             <ac:spMk id="10" creationId="{EEA281A1-0E77-084B-5368-307C0C5A65A8}"/>
-          </ac:spMkLst>
-        </pc:spChg>
-        <pc:spChg chg="del mod">
-          <ac:chgData name="John Rolzhausen" userId="f0fced98129e348e" providerId="LiveId" clId="{FAB81778-C2AB-48D5-BA9E-3E19BB729E3D}" dt="2025-11-24T21:24:20.979" v="2361" actId="478"/>
-          <ac:spMkLst>
-            <pc:docMk/>
-            <pc:sldMk cId="1376577602" sldId="270"/>
-            <ac:spMk id="11" creationId="{2A98106F-009F-7ECC-8190-72C6338D3C36}"/>
           </ac:spMkLst>
         </pc:spChg>
         <pc:spChg chg="add mod">
@@ -1393,70 +760,6 @@
             <ac:spMk id="12" creationId="{0593CE96-467E-FA2B-C2E6-6CACFAD301D6}"/>
           </ac:spMkLst>
         </pc:spChg>
-        <pc:spChg chg="add">
-          <ac:chgData name="John Rolzhausen" userId="f0fced98129e348e" providerId="LiveId" clId="{FAB81778-C2AB-48D5-BA9E-3E19BB729E3D}" dt="2025-11-24T21:38:12.113" v="2457"/>
-          <ac:spMkLst>
-            <pc:docMk/>
-            <pc:sldMk cId="1376577602" sldId="270"/>
-            <ac:spMk id="13" creationId="{AAB0186A-C5EF-7DBE-76B7-5A6B184869A9}"/>
-          </ac:spMkLst>
-        </pc:spChg>
-        <pc:spChg chg="del mod">
-          <ac:chgData name="John Rolzhausen" userId="f0fced98129e348e" providerId="LiveId" clId="{FAB81778-C2AB-48D5-BA9E-3E19BB729E3D}" dt="2025-11-24T21:24:11.415" v="2355" actId="478"/>
-          <ac:spMkLst>
-            <pc:docMk/>
-            <pc:sldMk cId="1376577602" sldId="270"/>
-            <ac:spMk id="14" creationId="{2B897132-2EDC-FCB8-72C5-B954F86FB02E}"/>
-          </ac:spMkLst>
-        </pc:spChg>
-        <pc:spChg chg="add">
-          <ac:chgData name="John Rolzhausen" userId="f0fced98129e348e" providerId="LiveId" clId="{FAB81778-C2AB-48D5-BA9E-3E19BB729E3D}" dt="2025-11-24T21:38:12.113" v="2457"/>
-          <ac:spMkLst>
-            <pc:docMk/>
-            <pc:sldMk cId="1376577602" sldId="270"/>
-            <ac:spMk id="16" creationId="{35536144-B9B7-0A76-BB48-431C884273E1}"/>
-          </ac:spMkLst>
-        </pc:spChg>
-        <pc:spChg chg="del">
-          <ac:chgData name="John Rolzhausen" userId="f0fced98129e348e" providerId="LiveId" clId="{FAB81778-C2AB-48D5-BA9E-3E19BB729E3D}" dt="2025-11-24T21:24:17.043" v="2359" actId="478"/>
-          <ac:spMkLst>
-            <pc:docMk/>
-            <pc:sldMk cId="1376577602" sldId="270"/>
-            <ac:spMk id="17" creationId="{C12C02B6-3D59-0D6F-BEDF-4AD2FFFD15B7}"/>
-          </ac:spMkLst>
-        </pc:spChg>
-        <pc:spChg chg="del mod">
-          <ac:chgData name="John Rolzhausen" userId="f0fced98129e348e" providerId="LiveId" clId="{FAB81778-C2AB-48D5-BA9E-3E19BB729E3D}" dt="2025-11-24T21:24:15.962" v="2358" actId="478"/>
-          <ac:spMkLst>
-            <pc:docMk/>
-            <pc:sldMk cId="1376577602" sldId="270"/>
-            <ac:spMk id="18" creationId="{EE09856C-1B7E-E1FB-F59C-D25232E9B6D1}"/>
-          </ac:spMkLst>
-        </pc:spChg>
-        <pc:spChg chg="del">
-          <ac:chgData name="John Rolzhausen" userId="f0fced98129e348e" providerId="LiveId" clId="{FAB81778-C2AB-48D5-BA9E-3E19BB729E3D}" dt="2025-11-24T21:24:29.954" v="2366" actId="478"/>
-          <ac:spMkLst>
-            <pc:docMk/>
-            <pc:sldMk cId="1376577602" sldId="270"/>
-            <ac:spMk id="20" creationId="{16E230DA-DE61-7EB7-123F-16CD4FB9EB75}"/>
-          </ac:spMkLst>
-        </pc:spChg>
-        <pc:spChg chg="del mod">
-          <ac:chgData name="John Rolzhausen" userId="f0fced98129e348e" providerId="LiveId" clId="{FAB81778-C2AB-48D5-BA9E-3E19BB729E3D}" dt="2025-11-24T21:24:28.745" v="2365" actId="478"/>
-          <ac:spMkLst>
-            <pc:docMk/>
-            <pc:sldMk cId="1376577602" sldId="270"/>
-            <ac:spMk id="21" creationId="{3471B379-5591-3662-29E1-2B11069A7A6E}"/>
-          </ac:spMkLst>
-        </pc:spChg>
-        <pc:spChg chg="add">
-          <ac:chgData name="John Rolzhausen" userId="f0fced98129e348e" providerId="LiveId" clId="{FAB81778-C2AB-48D5-BA9E-3E19BB729E3D}" dt="2025-11-24T21:38:12.113" v="2457"/>
-          <ac:spMkLst>
-            <pc:docMk/>
-            <pc:sldMk cId="1376577602" sldId="270"/>
-            <ac:spMk id="23" creationId="{328BCF22-48D6-9E40-CDB9-09FBF3BD4355}"/>
-          </ac:spMkLst>
-        </pc:spChg>
         <pc:spChg chg="mod">
           <ac:chgData name="John Rolzhausen" userId="f0fced98129e348e" providerId="LiveId" clId="{FAB81778-C2AB-48D5-BA9E-3E19BB729E3D}" dt="2025-11-24T22:04:43.282" v="2914" actId="14100"/>
           <ac:spMkLst>
@@ -1465,116 +768,12 @@
             <ac:spMk id="24" creationId="{3AA7BB41-61DC-42F8-6132-BAEA1AE157B9}"/>
           </ac:spMkLst>
         </pc:spChg>
-        <pc:spChg chg="add">
-          <ac:chgData name="John Rolzhausen" userId="f0fced98129e348e" providerId="LiveId" clId="{FAB81778-C2AB-48D5-BA9E-3E19BB729E3D}" dt="2025-11-24T21:38:12.113" v="2457"/>
-          <ac:spMkLst>
-            <pc:docMk/>
-            <pc:sldMk cId="1376577602" sldId="270"/>
-            <ac:spMk id="25" creationId="{2EC9D412-DDD8-81F7-8857-6F403EE2DBD0}"/>
-          </ac:spMkLst>
-        </pc:spChg>
-        <pc:spChg chg="add">
-          <ac:chgData name="John Rolzhausen" userId="f0fced98129e348e" providerId="LiveId" clId="{FAB81778-C2AB-48D5-BA9E-3E19BB729E3D}" dt="2025-11-24T21:38:12.113" v="2457"/>
-          <ac:spMkLst>
-            <pc:docMk/>
-            <pc:sldMk cId="1376577602" sldId="270"/>
-            <ac:spMk id="26" creationId="{954E8AB6-DC31-B507-6285-B589E257A129}"/>
-          </ac:spMkLst>
-        </pc:spChg>
-        <pc:spChg chg="add">
-          <ac:chgData name="John Rolzhausen" userId="f0fced98129e348e" providerId="LiveId" clId="{FAB81778-C2AB-48D5-BA9E-3E19BB729E3D}" dt="2025-11-24T21:38:12.113" v="2457"/>
-          <ac:spMkLst>
-            <pc:docMk/>
-            <pc:sldMk cId="1376577602" sldId="270"/>
-            <ac:spMk id="27" creationId="{844F8114-C13C-1B4F-B5FD-89E2ED3529C7}"/>
-          </ac:spMkLst>
-        </pc:spChg>
-        <pc:spChg chg="add">
-          <ac:chgData name="John Rolzhausen" userId="f0fced98129e348e" providerId="LiveId" clId="{FAB81778-C2AB-48D5-BA9E-3E19BB729E3D}" dt="2025-11-24T21:38:12.113" v="2457"/>
-          <ac:spMkLst>
-            <pc:docMk/>
-            <pc:sldMk cId="1376577602" sldId="270"/>
-            <ac:spMk id="29" creationId="{BF2EAB06-FF89-EBF5-94E6-6BA07C0829BA}"/>
-          </ac:spMkLst>
-        </pc:spChg>
-        <pc:spChg chg="del mod">
-          <ac:chgData name="John Rolzhausen" userId="f0fced98129e348e" providerId="LiveId" clId="{FAB81778-C2AB-48D5-BA9E-3E19BB729E3D}" dt="2025-11-24T21:24:26.835" v="2364" actId="478"/>
-          <ac:spMkLst>
-            <pc:docMk/>
-            <pc:sldMk cId="1376577602" sldId="270"/>
-            <ac:spMk id="30" creationId="{27259683-5264-68AB-7D73-22FC8E9C9547}"/>
-          </ac:spMkLst>
-        </pc:spChg>
-        <pc:spChg chg="add">
-          <ac:chgData name="John Rolzhausen" userId="f0fced98129e348e" providerId="LiveId" clId="{FAB81778-C2AB-48D5-BA9E-3E19BB729E3D}" dt="2025-11-24T21:38:12.113" v="2457"/>
-          <ac:spMkLst>
-            <pc:docMk/>
-            <pc:sldMk cId="1376577602" sldId="270"/>
-            <ac:spMk id="31" creationId="{5C627087-666A-DE43-77C9-1484EA6BD72E}"/>
-          </ac:spMkLst>
-        </pc:spChg>
-        <pc:spChg chg="add">
-          <ac:chgData name="John Rolzhausen" userId="f0fced98129e348e" providerId="LiveId" clId="{FAB81778-C2AB-48D5-BA9E-3E19BB729E3D}" dt="2025-11-24T21:38:12.113" v="2457"/>
-          <ac:spMkLst>
-            <pc:docMk/>
-            <pc:sldMk cId="1376577602" sldId="270"/>
-            <ac:spMk id="32" creationId="{62DB45DF-F551-0C3A-302A-E0C1F56DE5DF}"/>
-          </ac:spMkLst>
-        </pc:spChg>
-        <pc:spChg chg="del">
-          <ac:chgData name="John Rolzhausen" userId="f0fced98129e348e" providerId="LiveId" clId="{FAB81778-C2AB-48D5-BA9E-3E19BB729E3D}" dt="2025-11-24T21:24:31.096" v="2367" actId="478"/>
-          <ac:spMkLst>
-            <pc:docMk/>
-            <pc:sldMk cId="1376577602" sldId="270"/>
-            <ac:spMk id="34" creationId="{CDE9DF3D-7FC7-FE03-FA08-4F65E2A7B095}"/>
-          </ac:spMkLst>
-        </pc:spChg>
-        <pc:spChg chg="add">
-          <ac:chgData name="John Rolzhausen" userId="f0fced98129e348e" providerId="LiveId" clId="{FAB81778-C2AB-48D5-BA9E-3E19BB729E3D}" dt="2025-11-24T21:38:12.113" v="2457"/>
-          <ac:spMkLst>
-            <pc:docMk/>
-            <pc:sldMk cId="1376577602" sldId="270"/>
-            <ac:spMk id="35" creationId="{260B1B93-9403-3205-4508-82C3ECA697AE}"/>
-          </ac:spMkLst>
-        </pc:spChg>
-        <pc:spChg chg="del">
-          <ac:chgData name="John Rolzhausen" userId="f0fced98129e348e" providerId="LiveId" clId="{FAB81778-C2AB-48D5-BA9E-3E19BB729E3D}" dt="2025-11-24T21:24:32.289" v="2368" actId="478"/>
-          <ac:spMkLst>
-            <pc:docMk/>
-            <pc:sldMk cId="1376577602" sldId="270"/>
-            <ac:spMk id="36" creationId="{A0637A1A-18E1-3F10-E654-05E7531310BA}"/>
-          </ac:spMkLst>
-        </pc:spChg>
-        <pc:spChg chg="add del mod">
-          <ac:chgData name="John Rolzhausen" userId="f0fced98129e348e" providerId="LiveId" clId="{FAB81778-C2AB-48D5-BA9E-3E19BB729E3D}" dt="2025-11-24T22:01:47.209" v="2875" actId="478"/>
-          <ac:spMkLst>
-            <pc:docMk/>
-            <pc:sldMk cId="1376577602" sldId="270"/>
-            <ac:spMk id="37" creationId="{E0A889F9-DA6B-1E2C-11EA-17FB6C9B8DBB}"/>
-          </ac:spMkLst>
-        </pc:spChg>
         <pc:spChg chg="add mod">
           <ac:chgData name="John Rolzhausen" userId="f0fced98129e348e" providerId="LiveId" clId="{FAB81778-C2AB-48D5-BA9E-3E19BB729E3D}" dt="2025-11-24T22:08:55.424" v="2947" actId="1076"/>
           <ac:spMkLst>
             <pc:docMk/>
             <pc:sldMk cId="1376577602" sldId="270"/>
             <ac:spMk id="38" creationId="{E36431D6-D897-4DE6-956F-AE8DFA805328}"/>
-          </ac:spMkLst>
-        </pc:spChg>
-        <pc:spChg chg="add del mod">
-          <ac:chgData name="John Rolzhausen" userId="f0fced98129e348e" providerId="LiveId" clId="{FAB81778-C2AB-48D5-BA9E-3E19BB729E3D}" dt="2025-11-24T22:07:46.098" v="2934" actId="478"/>
-          <ac:spMkLst>
-            <pc:docMk/>
-            <pc:sldMk cId="1376577602" sldId="270"/>
-            <ac:spMk id="39" creationId="{2B221DE5-1DC1-A8BA-A6A4-D89FC4E55FD9}"/>
-          </ac:spMkLst>
-        </pc:spChg>
-        <pc:spChg chg="add del mod">
-          <ac:chgData name="John Rolzhausen" userId="f0fced98129e348e" providerId="LiveId" clId="{FAB81778-C2AB-48D5-BA9E-3E19BB729E3D}" dt="2025-11-24T22:08:54.073" v="2944" actId="1076"/>
-          <ac:spMkLst>
-            <pc:docMk/>
-            <pc:sldMk cId="1376577602" sldId="270"/>
-            <ac:spMk id="40" creationId="{44BBB945-8BE4-BBD5-8B47-86EEA35C08D5}"/>
           </ac:spMkLst>
         </pc:spChg>
       </pc:sldChg>
@@ -1695,28 +894,19 @@
           </ac:spMkLst>
         </pc:spChg>
       </pc:sldChg>
-      <pc:sldChg chg="modSp add del mod">
-        <pc:chgData name="John Rolzhausen" userId="f0fced98129e348e" providerId="LiveId" clId="{FAB81778-C2AB-48D5-BA9E-3E19BB729E3D}" dt="2025-11-24T22:12:40.546" v="3051" actId="47"/>
+      <pc:sldChg chg="add del">
+        <pc:chgData name="John Rolzhausen" userId="f0fced98129e348e" providerId="LiveId" clId="{FAB81778-C2AB-48D5-BA9E-3E19BB729E3D}" dt="2025-12-14T01:59:02.789" v="3073" actId="47"/>
         <pc:sldMkLst>
           <pc:docMk/>
-          <pc:sldMk cId="3818751414" sldId="274"/>
+          <pc:sldMk cId="987467116" sldId="274"/>
         </pc:sldMkLst>
-        <pc:spChg chg="mod">
-          <ac:chgData name="John Rolzhausen" userId="f0fced98129e348e" providerId="LiveId" clId="{FAB81778-C2AB-48D5-BA9E-3E19BB729E3D}" dt="2025-11-24T22:09:33.203" v="2979" actId="20577"/>
-          <ac:spMkLst>
-            <pc:docMk/>
-            <pc:sldMk cId="3818751414" sldId="274"/>
-            <ac:spMk id="2" creationId="{4485F07B-6E35-BC5A-7A13-6C3B431DCFCB}"/>
-          </ac:spMkLst>
-        </pc:spChg>
-        <pc:spChg chg="mod">
-          <ac:chgData name="John Rolzhausen" userId="f0fced98129e348e" providerId="LiveId" clId="{FAB81778-C2AB-48D5-BA9E-3E19BB729E3D}" dt="2025-11-24T22:12:24.741" v="3050"/>
-          <ac:spMkLst>
-            <pc:docMk/>
-            <pc:sldMk cId="3818751414" sldId="274"/>
-            <ac:spMk id="38" creationId="{B15CE887-26AF-801D-D403-DDC5D9011A3C}"/>
-          </ac:spMkLst>
-        </pc:spChg>
+      </pc:sldChg>
+      <pc:sldChg chg="add del">
+        <pc:chgData name="John Rolzhausen" userId="f0fced98129e348e" providerId="LiveId" clId="{FAB81778-C2AB-48D5-BA9E-3E19BB729E3D}" dt="2025-12-14T01:37:44.328" v="3063" actId="47"/>
+        <pc:sldMkLst>
+          <pc:docMk/>
+          <pc:sldMk cId="1936046896" sldId="274"/>
+        </pc:sldMkLst>
       </pc:sldChg>
     </pc:docChg>
   </pc:docChgLst>
@@ -1805,7 +995,7 @@
           <a:p>
             <a:fld id="{7F571194-8E21-4113-AD09-7A20562102BE}" type="datetimeFigureOut">
               <a:rPr lang="en-US" smtClean="0"/>
-              <a:t>11/24/2025</a:t>
+              <a:t>12/15/2025</a:t>
             </a:fld>
             <a:endParaRPr lang="en-US"/>
           </a:p>
@@ -11651,7 +10841,7 @@
           <a:p>
             <a:fld id="{CDB540FD-1622-4619-B8A4-2E34D7A0DA80}" type="datetimeFigureOut">
               <a:rPr lang="en-US" smtClean="0"/>
-              <a:t>11/24/2025</a:t>
+              <a:t>12/15/2025</a:t>
             </a:fld>
             <a:endParaRPr lang="en-US"/>
           </a:p>
@@ -11849,7 +11039,7 @@
           <a:p>
             <a:fld id="{CDB540FD-1622-4619-B8A4-2E34D7A0DA80}" type="datetimeFigureOut">
               <a:rPr lang="en-US" smtClean="0"/>
-              <a:t>11/24/2025</a:t>
+              <a:t>12/15/2025</a:t>
             </a:fld>
             <a:endParaRPr lang="en-US"/>
           </a:p>
@@ -12057,7 +11247,7 @@
           <a:p>
             <a:fld id="{CDB540FD-1622-4619-B8A4-2E34D7A0DA80}" type="datetimeFigureOut">
               <a:rPr lang="en-US" smtClean="0"/>
-              <a:t>11/24/2025</a:t>
+              <a:t>12/15/2025</a:t>
             </a:fld>
             <a:endParaRPr lang="en-US"/>
           </a:p>
@@ -12255,7 +11445,7 @@
           <a:p>
             <a:fld id="{CDB540FD-1622-4619-B8A4-2E34D7A0DA80}" type="datetimeFigureOut">
               <a:rPr lang="en-US" smtClean="0"/>
-              <a:t>11/24/2025</a:t>
+              <a:t>12/15/2025</a:t>
             </a:fld>
             <a:endParaRPr lang="en-US"/>
           </a:p>
@@ -12530,7 +11720,7 @@
           <a:p>
             <a:fld id="{CDB540FD-1622-4619-B8A4-2E34D7A0DA80}" type="datetimeFigureOut">
               <a:rPr lang="en-US" smtClean="0"/>
-              <a:t>11/24/2025</a:t>
+              <a:t>12/15/2025</a:t>
             </a:fld>
             <a:endParaRPr lang="en-US"/>
           </a:p>
@@ -12795,7 +11985,7 @@
           <a:p>
             <a:fld id="{CDB540FD-1622-4619-B8A4-2E34D7A0DA80}" type="datetimeFigureOut">
               <a:rPr lang="en-US" smtClean="0"/>
-              <a:t>11/24/2025</a:t>
+              <a:t>12/15/2025</a:t>
             </a:fld>
             <a:endParaRPr lang="en-US"/>
           </a:p>
@@ -13207,7 +12397,7 @@
           <a:p>
             <a:fld id="{CDB540FD-1622-4619-B8A4-2E34D7A0DA80}" type="datetimeFigureOut">
               <a:rPr lang="en-US" smtClean="0"/>
-              <a:t>11/24/2025</a:t>
+              <a:t>12/15/2025</a:t>
             </a:fld>
             <a:endParaRPr lang="en-US"/>
           </a:p>
@@ -13348,7 +12538,7 @@
           <a:p>
             <a:fld id="{CDB540FD-1622-4619-B8A4-2E34D7A0DA80}" type="datetimeFigureOut">
               <a:rPr lang="en-US" smtClean="0"/>
-              <a:t>11/24/2025</a:t>
+              <a:t>12/15/2025</a:t>
             </a:fld>
             <a:endParaRPr lang="en-US"/>
           </a:p>
@@ -13461,7 +12651,7 @@
           <a:p>
             <a:fld id="{CDB540FD-1622-4619-B8A4-2E34D7A0DA80}" type="datetimeFigureOut">
               <a:rPr lang="en-US" smtClean="0"/>
-              <a:t>11/24/2025</a:t>
+              <a:t>12/15/2025</a:t>
             </a:fld>
             <a:endParaRPr lang="en-US"/>
           </a:p>
@@ -13772,7 +12962,7 @@
           <a:p>
             <a:fld id="{CDB540FD-1622-4619-B8A4-2E34D7A0DA80}" type="datetimeFigureOut">
               <a:rPr lang="en-US" smtClean="0"/>
-              <a:t>11/24/2025</a:t>
+              <a:t>12/15/2025</a:t>
             </a:fld>
             <a:endParaRPr lang="en-US"/>
           </a:p>
@@ -14060,7 +13250,7 @@
           <a:p>
             <a:fld id="{CDB540FD-1622-4619-B8A4-2E34D7A0DA80}" type="datetimeFigureOut">
               <a:rPr lang="en-US" smtClean="0"/>
-              <a:t>11/24/2025</a:t>
+              <a:t>12/15/2025</a:t>
             </a:fld>
             <a:endParaRPr lang="en-US"/>
           </a:p>
@@ -14301,7 +13491,7 @@
           <a:p>
             <a:fld id="{CDB540FD-1622-4619-B8A4-2E34D7A0DA80}" type="datetimeFigureOut">
               <a:rPr lang="en-US" smtClean="0"/>
-              <a:t>11/24/2025</a:t>
+              <a:t>12/15/2025</a:t>
             </a:fld>
             <a:endParaRPr lang="en-US"/>
           </a:p>
@@ -18404,7 +17594,7 @@
         <p:spPr>
           <a:xfrm>
             <a:off x="6513871" y="2898086"/>
-            <a:ext cx="4011239" cy="2308324"/>
+            <a:ext cx="4011239" cy="1754326"/>
           </a:xfrm>
           <a:prstGeom prst="rect">
             <a:avLst/>
@@ -18463,28 +17653,7 @@
             <a:br>
               <a:rPr lang="en-US" sz="1200" dirty="0"/>
             </a:br>
-            <a:r>
-              <a:rPr lang="en-US" sz="1200" dirty="0"/>
-              <a:t>⚠️ ATTENTION NEEDED:</a:t>
-            </a:r>
-          </a:p>
-          <a:p>
-            <a:r>
-              <a:rPr lang="en-US" sz="1200" dirty="0"/>
-              <a:t>- 3 submissions flagged for review</a:t>
-            </a:r>
-          </a:p>
-          <a:p>
-            <a:r>
-              <a:rPr lang="en-US" sz="1200" dirty="0"/>
-              <a:t>- 13 countries have not started (deadline in 9 days)</a:t>
-            </a:r>
-          </a:p>
-          <a:p>
-            <a:r>
-              <a:rPr lang="en-US" sz="1200" dirty="0"/>
-              <a:t>- Brazil: Consistently late (see notes)</a:t>
-            </a:r>
+            <a:endParaRPr lang="en-US" sz="1200" dirty="0"/>
           </a:p>
         </p:txBody>
       </p:sp>
@@ -18745,7 +17914,7 @@
         <p:spPr>
           <a:xfrm>
             <a:off x="550606" y="681676"/>
-            <a:ext cx="3431459" cy="26868894"/>
+            <a:ext cx="3431459" cy="6401753"/>
           </a:xfrm>
           <a:prstGeom prst="rect">
             <a:avLst/>
@@ -18760,7 +17929,16 @@
           <a:p>
             <a:r>
               <a:rPr lang="en-US" sz="1000" dirty="0"/>
-              <a:t>DATA SOURCES:</a:t>
+              <a:t>NOTES:</a:t>
+            </a:r>
+          </a:p>
+          <a:p>
+            <a:endParaRPr lang="en-US" sz="1000" dirty="0"/>
+          </a:p>
+          <a:p>
+            <a:r>
+              <a:rPr lang="en-US" sz="1000" dirty="0"/>
+              <a:t>Data Sources:</a:t>
             </a:r>
           </a:p>
           <a:p>
@@ -18774,7 +17952,49 @@
             </a:r>
             <a:r>
               <a:rPr lang="en-US" sz="1000" dirty="0"/>
-              <a:t> (current flagged submissions)</a:t>
+              <a:t> (all countries, current month)</a:t>
+            </a:r>
+          </a:p>
+          <a:p>
+            <a:r>
+              <a:rPr lang="en-US" sz="1000" dirty="0"/>
+              <a:t>- </a:t>
+            </a:r>
+            <a:r>
+              <a:rPr lang="en-US" sz="1000" dirty="0" err="1"/>
+              <a:t>tbl_Countries</a:t>
+            </a:r>
+            <a:r>
+              <a:rPr lang="en-US" sz="1000" dirty="0"/>
+              <a:t> (for country names, regions)</a:t>
+            </a:r>
+          </a:p>
+          <a:p>
+            <a:r>
+              <a:rPr lang="en-US" sz="1000" dirty="0"/>
+              <a:t>- </a:t>
+            </a:r>
+            <a:r>
+              <a:rPr lang="en-US" sz="1000" dirty="0" err="1"/>
+              <a:t>tbl_CountryTestTypes</a:t>
+            </a:r>
+            <a:r>
+              <a:rPr lang="en-US" sz="1000" dirty="0"/>
+              <a:t> (for expected test type count)</a:t>
+            </a:r>
+          </a:p>
+          <a:p>
+            <a:r>
+              <a:rPr lang="en-US" sz="1000" dirty="0"/>
+              <a:t>- </a:t>
+            </a:r>
+            <a:r>
+              <a:rPr lang="en-US" sz="1000" dirty="0" err="1"/>
+              <a:t>tbl_UserCountries</a:t>
+            </a:r>
+            <a:r>
+              <a:rPr lang="en-US" sz="1000" dirty="0"/>
+              <a:t> (for coordinator info)</a:t>
             </a:r>
           </a:p>
           <a:p>
@@ -18788,302 +18008,69 @@
             </a:r>
             <a:r>
               <a:rPr lang="en-US" sz="1000" dirty="0"/>
-              <a:t> (detailed flag information)</a:t>
-            </a:r>
-          </a:p>
-          <a:p>
-            <a:r>
-              <a:rPr lang="en-US" sz="1000" dirty="0"/>
-              <a:t>- </a:t>
+              <a:t> (for flagged count)</a:t>
+            </a:r>
+          </a:p>
+          <a:p>
+            <a:endParaRPr lang="en-US" sz="1000" dirty="0"/>
+          </a:p>
+          <a:p>
+            <a:r>
+              <a:rPr lang="en-US" sz="1000" dirty="0"/>
+              <a:t>Page Context:</a:t>
+            </a:r>
+          </a:p>
+          <a:p>
+            <a:r>
+              <a:rPr lang="en-US" sz="1000" dirty="0"/>
+              <a:t>- Month selector at top (defaults to current month)</a:t>
+            </a:r>
+          </a:p>
+          <a:p>
+            <a:r>
+              <a:rPr lang="en-US" sz="1000" dirty="0"/>
+              <a:t>- Shows ALL countries, not filtered by user</a:t>
+            </a:r>
+          </a:p>
+          <a:p>
+            <a:r>
+              <a:rPr lang="en-US" sz="1000" dirty="0"/>
+              <a:t>- Real-time data (refreshes every 5 minutes)</a:t>
+            </a:r>
+          </a:p>
+          <a:p>
+            <a:endParaRPr lang="en-US" sz="1000" dirty="0"/>
+          </a:p>
+          <a:p>
+            <a:r>
+              <a:rPr lang="en-US" sz="1000" dirty="0"/>
+              <a:t>Key Metrics Cards:</a:t>
+            </a:r>
+          </a:p>
+          <a:p>
+            <a:r>
+              <a:rPr lang="en-US" sz="1000" dirty="0"/>
+              <a:t>1. Submitted: Count where Status IN ('</a:t>
             </a:r>
             <a:r>
               <a:rPr lang="en-US" sz="1000" dirty="0" err="1"/>
-              <a:t>tbl_Countries</a:t>
-            </a:r>
-            <a:r>
-              <a:rPr lang="en-US" sz="1000" dirty="0"/>
-              <a:t> (country context)</a:t>
-            </a:r>
-          </a:p>
-          <a:p>
-            <a:r>
-              <a:rPr lang="en-US" sz="1000" dirty="0"/>
-              <a:t>- </a:t>
-            </a:r>
-            <a:r>
-              <a:rPr lang="en-US" sz="1000" dirty="0" err="1"/>
-              <a:t>tbl_TestTypes</a:t>
-            </a:r>
-            <a:r>
-              <a:rPr lang="en-US" sz="1000" dirty="0"/>
-              <a:t> (test type details)</a:t>
-            </a:r>
-          </a:p>
-          <a:p>
-            <a:r>
-              <a:rPr lang="en-US" sz="1000" dirty="0"/>
-              <a:t>- </a:t>
-            </a:r>
-            <a:r>
-              <a:rPr lang="en-US" sz="1000" dirty="0" err="1"/>
-              <a:t>tbl_VolumeSubmissions</a:t>
-            </a:r>
-            <a:r>
-              <a:rPr lang="en-US" sz="1000" dirty="0"/>
-              <a:t> (historical - for prior month comparison)</a:t>
-            </a:r>
-          </a:p>
-          <a:p>
-            <a:r>
-              <a:rPr lang="en-US" sz="1000" dirty="0"/>
-              <a:t>- </a:t>
-            </a:r>
-            <a:r>
-              <a:rPr lang="en-US" sz="1000" dirty="0" err="1"/>
-              <a:t>tbl_SystemConfig</a:t>
-            </a:r>
-            <a:r>
-              <a:rPr lang="en-US" sz="1000" dirty="0"/>
-              <a:t> (for threshold values)</a:t>
-            </a:r>
-          </a:p>
-          <a:p>
-            <a:endParaRPr lang="en-US" sz="1000" dirty="0"/>
-          </a:p>
-          <a:p>
-            <a:r>
-              <a:rPr lang="en-US" sz="1000" dirty="0"/>
-              <a:t>PAGE CONTEXT:</a:t>
-            </a:r>
-          </a:p>
-          <a:p>
-            <a:r>
-              <a:rPr lang="en-US" sz="1000" dirty="0"/>
-              <a:t>- Shows one flagged submission at a time (focused review)</a:t>
-            </a:r>
-          </a:p>
-          <a:p>
-            <a:r>
-              <a:rPr lang="en-US" sz="1000" dirty="0"/>
-              <a:t>- Queue filters to Status = 'Flagged' OR </a:t>
-            </a:r>
-            <a:r>
-              <a:rPr lang="en-US" sz="1000" dirty="0" err="1"/>
-              <a:t>DataQualityFlags.Status</a:t>
-            </a:r>
-            <a:r>
-              <a:rPr lang="en-US" sz="1000" dirty="0"/>
-              <a:t> = 'Open'</a:t>
-            </a:r>
-          </a:p>
-          <a:p>
-            <a:r>
-              <a:rPr lang="en-US" sz="1000" dirty="0"/>
-              <a:t>- Orders by Priority (Critical &gt; High &gt; Medium &gt; Low), then date</a:t>
-            </a:r>
-          </a:p>
-          <a:p>
-            <a:r>
-              <a:rPr lang="en-US" sz="1000" dirty="0"/>
-              <a:t>- Analyst can navigate through queue sequentially or jump to specific item</a:t>
-            </a:r>
-          </a:p>
-          <a:p>
-            <a:endParaRPr lang="en-US" sz="1000" dirty="0"/>
-          </a:p>
-          <a:p>
-            <a:r>
-              <a:rPr lang="en-US" sz="1000" dirty="0"/>
-              <a:t>REVIEW CARD SECTIONS:</a:t>
-            </a:r>
-          </a:p>
-          <a:p>
-            <a:endParaRPr lang="en-US" sz="1000" dirty="0"/>
-          </a:p>
-          <a:p>
-            <a:r>
-              <a:rPr lang="en-US" sz="1000" dirty="0"/>
-              <a:t>1. Card Header:</a:t>
-            </a:r>
-          </a:p>
-          <a:p>
-            <a:r>
-              <a:rPr lang="en-US" sz="1000" dirty="0"/>
-              <a:t>   - Submission ID (clickable - opens full history)</a:t>
-            </a:r>
-          </a:p>
-          <a:p>
-            <a:r>
-              <a:rPr lang="en-US" sz="1000" dirty="0"/>
-              <a:t>   - Coordinator info (email clickable - opens communication)</a:t>
-            </a:r>
-          </a:p>
-          <a:p>
-            <a:r>
-              <a:rPr lang="en-US" sz="1000" dirty="0"/>
-              <a:t>   - Flag count and types listed</a:t>
-            </a:r>
-          </a:p>
-          <a:p>
-            <a:r>
-              <a:rPr lang="en-US" sz="1000" dirty="0"/>
-              <a:t>   </a:t>
-            </a:r>
-          </a:p>
-          <a:p>
-            <a:r>
-              <a:rPr lang="en-US" sz="1000" dirty="0"/>
-              <a:t>2. Comparison Table:</a:t>
-            </a:r>
-          </a:p>
-          <a:p>
-            <a:r>
-              <a:rPr lang="en-US" sz="1000" dirty="0"/>
-              <a:t>   - Shows all test types in submission</a:t>
-            </a:r>
-          </a:p>
-          <a:p>
-            <a:r>
-              <a:rPr lang="en-US" sz="1000" dirty="0"/>
-              <a:t>   - Columns: Submitted, Budget, Prior Month, Variance</a:t>
-            </a:r>
-          </a:p>
-          <a:p>
-            <a:r>
-              <a:rPr lang="en-US" sz="1000" dirty="0"/>
-              <a:t>   - Variance calculation: ((Submitted - Prior Month) / Prior Month) * 100</a:t>
-            </a:r>
-          </a:p>
-          <a:p>
-            <a:r>
-              <a:rPr lang="en-US" sz="1000" dirty="0"/>
-              <a:t>   - Color coding: Red if &gt;threshold, Green if within tolerance</a:t>
-            </a:r>
-          </a:p>
-          <a:p>
-            <a:r>
-              <a:rPr lang="en-US" sz="1000" dirty="0"/>
-              <a:t>   - Prior Month data from </a:t>
-            </a:r>
-            <a:r>
-              <a:rPr lang="en-US" sz="1000" dirty="0" err="1"/>
-              <a:t>tbl_VolumeSubmissions</a:t>
-            </a:r>
-            <a:r>
-              <a:rPr lang="en-US" sz="1000" dirty="0"/>
-              <a:t> WHERE </a:t>
-            </a:r>
-            <a:r>
-              <a:rPr lang="en-US" sz="1000" dirty="0" err="1"/>
-              <a:t>SubmissionMonth</a:t>
-            </a:r>
-            <a:r>
-              <a:rPr lang="en-US" sz="1000" dirty="0"/>
-              <a:t> = [Current-1]</a:t>
-            </a:r>
-          </a:p>
-          <a:p>
-            <a:r>
-              <a:rPr lang="en-US" sz="1000" dirty="0"/>
-              <a:t>   - Budget from most recent budget submission for that country/test</a:t>
-            </a:r>
-          </a:p>
-          <a:p>
-            <a:endParaRPr lang="en-US" sz="1000" dirty="0"/>
-          </a:p>
-          <a:p>
-            <a:r>
-              <a:rPr lang="en-US" sz="1000" dirty="0"/>
-              <a:t>3. Anomaly Details:</a:t>
-            </a:r>
-          </a:p>
-          <a:p>
-            <a:r>
-              <a:rPr lang="en-US" sz="1000" dirty="0"/>
-              <a:t>   - Auto-generated analysis based on flag type</a:t>
-            </a:r>
-          </a:p>
-          <a:p>
-            <a:r>
-              <a:rPr lang="en-US" sz="1000" dirty="0"/>
-              <a:t>   - Shows specific numbers and percentages</a:t>
-            </a:r>
-          </a:p>
-          <a:p>
-            <a:r>
-              <a:rPr lang="en-US" sz="1000" dirty="0"/>
-              <a:t>   - Historical context (6-month average)</a:t>
-            </a:r>
-          </a:p>
-          <a:p>
-            <a:r>
-              <a:rPr lang="en-US" sz="1000" dirty="0"/>
-              <a:t>   - Suggested possible causes (predefined list based on patterns)</a:t>
-            </a:r>
-          </a:p>
-          <a:p>
-            <a:r>
-              <a:rPr lang="en-US" sz="1000" dirty="0"/>
-              <a:t>   </a:t>
-            </a:r>
-          </a:p>
-          <a:p>
-            <a:r>
-              <a:rPr lang="en-US" sz="1000" dirty="0"/>
-              <a:t>4. Coordinator Notes:</a:t>
-            </a:r>
-          </a:p>
-          <a:p>
-            <a:r>
-              <a:rPr lang="en-US" sz="1000" dirty="0"/>
-              <a:t>   - Pulled from </a:t>
-            </a:r>
-            <a:r>
-              <a:rPr lang="en-US" sz="1000" dirty="0" err="1"/>
-              <a:t>VolumeSubmissions.ValidationNotes</a:t>
-            </a:r>
-            <a:endParaRPr lang="en-US" sz="1000" dirty="0"/>
-          </a:p>
-          <a:p>
-            <a:r>
-              <a:rPr lang="en-US" sz="1000" dirty="0"/>
-              <a:t>   - Shows if coordinator provided explanation during submission</a:t>
-            </a:r>
-          </a:p>
-          <a:p>
-            <a:r>
-              <a:rPr lang="en-US" sz="1000" dirty="0"/>
-              <a:t>   - Empty if no notes provided</a:t>
-            </a:r>
-          </a:p>
-          <a:p>
-            <a:endParaRPr lang="en-US" sz="1000" dirty="0"/>
-          </a:p>
-          <a:p>
-            <a:r>
-              <a:rPr lang="en-US" sz="1000" dirty="0"/>
-              <a:t>ANALYST ACTIONS:</a:t>
-            </a:r>
-          </a:p>
-          <a:p>
-            <a:endParaRPr lang="en-US" sz="1000" dirty="0"/>
-          </a:p>
-          <a:p>
-            <a:r>
-              <a:rPr lang="en-US" sz="1000" dirty="0"/>
-              <a:t>1. Approve &amp; Continue:</a:t>
-            </a:r>
-          </a:p>
-          <a:p>
-            <a:r>
-              <a:rPr lang="en-US" sz="1000" dirty="0"/>
-              <a:t>   - Changes submission Status to 'Validated'</a:t>
-            </a:r>
-          </a:p>
-          <a:p>
-            <a:r>
-              <a:rPr lang="en-US" sz="1000" dirty="0"/>
-              <a:t>   - Changes all related </a:t>
+              <a:t>Submitted','Validated','Flagged','Approved</a:t>
+            </a:r>
+            <a:r>
+              <a:rPr lang="en-US" sz="1000" dirty="0"/>
+              <a:t>')</a:t>
+            </a:r>
+          </a:p>
+          <a:p>
+            <a:r>
+              <a:rPr lang="en-US" sz="1000" dirty="0"/>
+              <a:t>2. Pending: Count where Status = 'Submitted' (awaiting first review)</a:t>
+            </a:r>
+          </a:p>
+          <a:p>
+            <a:r>
+              <a:rPr lang="en-US" sz="1000" dirty="0"/>
+              <a:t>3. Flagged: Count where Status = 'Flagged' OR </a:t>
             </a:r>
             <a:r>
               <a:rPr lang="en-US" sz="1000" dirty="0" err="1"/>
@@ -19091,746 +18078,114 @@
             </a:r>
             <a:r>
               <a:rPr lang="en-US" sz="1000" dirty="0"/>
-              <a:t> Status to 'Dismissed'</a:t>
-            </a:r>
-          </a:p>
-          <a:p>
-            <a:r>
-              <a:rPr lang="en-US" sz="1000" dirty="0"/>
-              <a:t>   - Sets </a:t>
+              <a:t> &gt; 0</a:t>
+            </a:r>
+          </a:p>
+          <a:p>
+            <a:r>
+              <a:rPr lang="en-US" sz="1000" dirty="0"/>
+              <a:t>4. Approved: Count where Status = 'Approved'</a:t>
+            </a:r>
+          </a:p>
+          <a:p>
+            <a:endParaRPr lang="en-US" sz="1000" dirty="0"/>
+          </a:p>
+          <a:p>
+            <a:r>
+              <a:rPr lang="en-US" sz="1000" dirty="0"/>
+              <a:t>Status Calculation:</a:t>
+            </a:r>
+          </a:p>
+          <a:p>
+            <a:r>
+              <a:rPr lang="en-US" sz="1000" dirty="0"/>
+              <a:t>- 🟢 Approved: Status = 'Approved'</a:t>
+            </a:r>
+          </a:p>
+          <a:p>
+            <a:r>
+              <a:rPr lang="en-US" sz="1000" dirty="0"/>
+              <a:t>- 🟡 Validated: Status = 'Validated'</a:t>
+            </a:r>
+          </a:p>
+          <a:p>
+            <a:r>
+              <a:rPr lang="en-US" sz="1000" dirty="0"/>
+              <a:t>- 🟠 Flagged: Status = 'Flagged' OR has active data quality flags</a:t>
+            </a:r>
+          </a:p>
+          <a:p>
+            <a:r>
+              <a:rPr lang="en-US" sz="1000" dirty="0"/>
+              <a:t>- 🔵 Submitted: Status = 'Submitted' (new, not yet reviewed)</a:t>
+            </a:r>
+          </a:p>
+          <a:p>
+            <a:r>
+              <a:rPr lang="en-US" sz="1000" dirty="0"/>
+              <a:t>- ⚪ Draft: Status = 'Draft' (started but not submitted)</a:t>
+            </a:r>
+          </a:p>
+          <a:p>
+            <a:r>
+              <a:rPr lang="en-US" sz="1000" dirty="0"/>
+              <a:t>- 🔴 Not Started: No record exists for this country/month</a:t>
+            </a:r>
+          </a:p>
+          <a:p>
+            <a:endParaRPr lang="en-US" sz="1000" dirty="0"/>
+          </a:p>
+          <a:p>
+            <a:r>
+              <a:rPr lang="en-US" sz="1000" dirty="0"/>
+              <a:t>Tests Column:</a:t>
+            </a:r>
+          </a:p>
+          <a:p>
+            <a:r>
+              <a:rPr lang="en-US" sz="1000" dirty="0"/>
+              <a:t>- Shows: [Submitted] / [Expected]</a:t>
+            </a:r>
+          </a:p>
+          <a:p>
+            <a:r>
+              <a:rPr lang="en-US" sz="1000" dirty="0"/>
+              <a:t>- Example: 3/3 means all 3 expected test types submitted</a:t>
+            </a:r>
+          </a:p>
+          <a:p>
+            <a:r>
+              <a:rPr lang="en-US" sz="1000" dirty="0"/>
+              <a:t>- Example: 2/3 means missing 1 test type</a:t>
+            </a:r>
+          </a:p>
+          <a:p>
+            <a:r>
+              <a:rPr lang="en-US" sz="1000" dirty="0"/>
+              <a:t>- Expected count from </a:t>
             </a:r>
             <a:r>
               <a:rPr lang="en-US" sz="1000" dirty="0" err="1"/>
-              <a:t>ValidatedDate</a:t>
-            </a:r>
-            <a:r>
-              <a:rPr lang="en-US" sz="1000" dirty="0"/>
-              <a:t>, </a:t>
+              <a:t>tbl_CountryTestTypes</a:t>
+            </a:r>
+            <a:r>
+              <a:rPr lang="en-US" sz="1000" dirty="0"/>
+              <a:t> WHERE </a:t>
             </a:r>
             <a:r>
               <a:rPr lang="en-US" sz="1000" dirty="0" err="1"/>
-              <a:t>ValidatedByEmail</a:t>
-            </a:r>
-            <a:r>
-              <a:rPr lang="en-US" sz="1000" dirty="0"/>
-              <a:t>, </a:t>
-            </a:r>
-            <a:r>
-              <a:rPr lang="en-US" sz="1000" dirty="0" err="1"/>
-              <a:t>ValidatedByName</a:t>
-            </a:r>
+              <a:t>IsActive</a:t>
+            </a:r>
+            <a:r>
+              <a:rPr lang="en-US" sz="1000" dirty="0"/>
+              <a:t> = Yes</a:t>
+            </a:r>
+          </a:p>
+          <a:p>
             <a:endParaRPr lang="en-US" sz="1000" dirty="0"/>
           </a:p>
           <a:p>
-            <a:r>
-              <a:rPr lang="en-US" sz="1000" dirty="0"/>
-              <a:t>   - Adds analyst notes to </a:t>
-            </a:r>
-            <a:r>
-              <a:rPr lang="en-US" sz="1000" dirty="0" err="1"/>
-              <a:t>ValidationNotes</a:t>
-            </a:r>
-            <a:r>
-              <a:rPr lang="en-US" sz="1000" dirty="0"/>
-              <a:t> field</a:t>
-            </a:r>
-          </a:p>
-          <a:p>
-            <a:r>
-              <a:rPr lang="en-US" sz="1000" dirty="0"/>
-              <a:t>   - Logs action in </a:t>
-            </a:r>
-            <a:r>
-              <a:rPr lang="en-US" sz="1000" dirty="0" err="1"/>
-              <a:t>tbl_SubmissionHistory</a:t>
-            </a:r>
             <a:endParaRPr lang="en-US" sz="1000" dirty="0"/>
-          </a:p>
-          <a:p>
-            <a:r>
-              <a:rPr lang="en-US" sz="1000" dirty="0"/>
-              <a:t>   - Auto-advances to next item in queue</a:t>
-            </a:r>
-          </a:p>
-          <a:p>
-            <a:r>
-              <a:rPr lang="en-US" sz="1000" dirty="0"/>
-              <a:t>   - Sends email notification to coordinator (approved)</a:t>
-            </a:r>
-          </a:p>
-          <a:p>
-            <a:endParaRPr lang="en-US" sz="1000" dirty="0"/>
-          </a:p>
-          <a:p>
-            <a:r>
-              <a:rPr lang="en-US" sz="1000" dirty="0"/>
-              <a:t>2. Request Clarification:</a:t>
-            </a:r>
-          </a:p>
-          <a:p>
-            <a:r>
-              <a:rPr lang="en-US" sz="1000" dirty="0"/>
-              <a:t>   - Keeps Status as 'Flagged'</a:t>
-            </a:r>
-          </a:p>
-          <a:p>
-            <a:r>
-              <a:rPr lang="en-US" sz="1000" dirty="0"/>
-              <a:t>   - Changes </a:t>
-            </a:r>
-            <a:r>
-              <a:rPr lang="en-US" sz="1000" dirty="0" err="1"/>
-              <a:t>DataQualityFlags</a:t>
-            </a:r>
-            <a:r>
-              <a:rPr lang="en-US" sz="1000" dirty="0"/>
-              <a:t> Status to 'Pending Response'</a:t>
-            </a:r>
-          </a:p>
-          <a:p>
-            <a:r>
-              <a:rPr lang="en-US" sz="1000" dirty="0"/>
-              <a:t>   - Sends email to coordinator with analyst's questions</a:t>
-            </a:r>
-          </a:p>
-          <a:p>
-            <a:r>
-              <a:rPr lang="en-US" sz="1000" dirty="0"/>
-              <a:t>   - Logs communication in </a:t>
-            </a:r>
-            <a:r>
-              <a:rPr lang="en-US" sz="1000" dirty="0" err="1"/>
-              <a:t>tbl_Communications</a:t>
-            </a:r>
-            <a:endParaRPr lang="en-US" sz="1000" dirty="0"/>
-          </a:p>
-          <a:p>
-            <a:r>
-              <a:rPr lang="en-US" sz="1000" dirty="0"/>
-              <a:t>   - Submission moves to "Waiting for Response" queue</a:t>
-            </a:r>
-          </a:p>
-          <a:p>
-            <a:r>
-              <a:rPr lang="en-US" sz="1000" dirty="0"/>
-              <a:t>   - Coordinator receives email with link to respond</a:t>
-            </a:r>
-          </a:p>
-          <a:p>
-            <a:r>
-              <a:rPr lang="en-US" sz="1000" dirty="0"/>
-              <a:t>   - Analyst notified when coordinator responds</a:t>
-            </a:r>
-          </a:p>
-          <a:p>
-            <a:endParaRPr lang="en-US" sz="1000" dirty="0"/>
-          </a:p>
-          <a:p>
-            <a:r>
-              <a:rPr lang="en-US" sz="1000" dirty="0"/>
-              <a:t>3. Manual Adjust:</a:t>
-            </a:r>
-          </a:p>
-          <a:p>
-            <a:r>
-              <a:rPr lang="en-US" sz="1000" dirty="0"/>
-              <a:t>   - Opens inline edit form</a:t>
-            </a:r>
-          </a:p>
-          <a:p>
-            <a:r>
-              <a:rPr lang="en-US" sz="1000" dirty="0"/>
-              <a:t>   - Shows current values in editable fields</a:t>
-            </a:r>
-          </a:p>
-          <a:p>
-            <a:r>
-              <a:rPr lang="en-US" sz="1000" dirty="0"/>
-              <a:t>   - Requires reason code (dropdown + free text)</a:t>
-            </a:r>
-          </a:p>
-          <a:p>
-            <a:r>
-              <a:rPr lang="en-US" sz="1000" dirty="0"/>
-              <a:t>   - Changes Status to 'Validated'</a:t>
-            </a:r>
-          </a:p>
-          <a:p>
-            <a:r>
-              <a:rPr lang="en-US" sz="1000" dirty="0"/>
-              <a:t>   - Logs original and new values in </a:t>
-            </a:r>
-            <a:r>
-              <a:rPr lang="en-US" sz="1000" dirty="0" err="1"/>
-              <a:t>tbl_SubmissionHistory</a:t>
-            </a:r>
-            <a:endParaRPr lang="en-US" sz="1000" dirty="0"/>
-          </a:p>
-          <a:p>
-            <a:r>
-              <a:rPr lang="en-US" sz="1000" dirty="0"/>
-              <a:t>   - Sets flag: </a:t>
-            </a:r>
-            <a:r>
-              <a:rPr lang="en-US" sz="1000" dirty="0" err="1"/>
-              <a:t>ManuallyAdjusted</a:t>
-            </a:r>
-            <a:r>
-              <a:rPr lang="en-US" sz="1000" dirty="0"/>
-              <a:t> = Yes</a:t>
-            </a:r>
-          </a:p>
-          <a:p>
-            <a:r>
-              <a:rPr lang="en-US" sz="1000" dirty="0"/>
-              <a:t>   - Audit trail preserved</a:t>
-            </a:r>
-          </a:p>
-          <a:p>
-            <a:r>
-              <a:rPr lang="en-US" sz="1000" dirty="0"/>
-              <a:t>   - Coordinator notified of adjustment with explanation</a:t>
-            </a:r>
-          </a:p>
-          <a:p>
-            <a:endParaRPr lang="en-US" sz="1000" dirty="0"/>
-          </a:p>
-          <a:p>
-            <a:r>
-              <a:rPr lang="en-US" sz="1000" dirty="0"/>
-              <a:t>4. Skip for Now:</a:t>
-            </a:r>
-          </a:p>
-          <a:p>
-            <a:r>
-              <a:rPr lang="en-US" sz="1000" dirty="0"/>
-              <a:t>   - No status changes</a:t>
-            </a:r>
-          </a:p>
-          <a:p>
-            <a:r>
-              <a:rPr lang="en-US" sz="1000" dirty="0"/>
-              <a:t>   - Moves to end of review queue</a:t>
-            </a:r>
-          </a:p>
-          <a:p>
-            <a:r>
-              <a:rPr lang="en-US" sz="1000" dirty="0"/>
-              <a:t>   - Allows analyst to come back later</a:t>
-            </a:r>
-          </a:p>
-          <a:p>
-            <a:r>
-              <a:rPr lang="en-US" sz="1000" dirty="0"/>
-              <a:t>   - Logs that item was skipped (analytics on difficult reviews)</a:t>
-            </a:r>
-          </a:p>
-          <a:p>
-            <a:endParaRPr lang="en-US" sz="1000" dirty="0"/>
-          </a:p>
-          <a:p>
-            <a:r>
-              <a:rPr lang="en-US" sz="1000" dirty="0"/>
-              <a:t>RESOLUTION DROPDOWN:</a:t>
-            </a:r>
-          </a:p>
-          <a:p>
-            <a:r>
-              <a:rPr lang="en-US" sz="1000" dirty="0"/>
-              <a:t>- Approve: Standard approval (no edits needed)</a:t>
-            </a:r>
-          </a:p>
-          <a:p>
-            <a:r>
-              <a:rPr lang="en-US" sz="1000" dirty="0"/>
-              <a:t>- Request Clarification: Send questions to coordinator</a:t>
-            </a:r>
-          </a:p>
-          <a:p>
-            <a:r>
-              <a:rPr lang="en-US" sz="1000" dirty="0"/>
-              <a:t>- Reject: Not used often (sends back for resubmission)</a:t>
-            </a:r>
-          </a:p>
-          <a:p>
-            <a:r>
-              <a:rPr lang="en-US" sz="1000" dirty="0"/>
-              <a:t>- Manually Adjust: Analyst makes corrections</a:t>
-            </a:r>
-          </a:p>
-          <a:p>
-            <a:endParaRPr lang="en-US" sz="1000" dirty="0"/>
-          </a:p>
-          <a:p>
-            <a:r>
-              <a:rPr lang="en-US" sz="1000" dirty="0"/>
-              <a:t>MESSAGE TEMPLATES (Request Clarification):</a:t>
-            </a:r>
-          </a:p>
-          <a:p>
-            <a:r>
-              <a:rPr lang="en-US" sz="1000" dirty="0"/>
-              <a:t>- "Missing Data Explanation" - "Please provide explanation for zero volumes"</a:t>
-            </a:r>
-          </a:p>
-          <a:p>
-            <a:r>
-              <a:rPr lang="en-US" sz="1000" dirty="0"/>
-              <a:t>- "Variance Explanation" - "Please explain significant variance from prior month"</a:t>
-            </a:r>
-          </a:p>
-          <a:p>
-            <a:r>
-              <a:rPr lang="en-US" sz="1000" dirty="0"/>
-              <a:t>- "Budget Misalignment" - "Volumes significantly different from budget, please verify"</a:t>
-            </a:r>
-          </a:p>
-          <a:p>
-            <a:r>
-              <a:rPr lang="en-US" sz="1000" dirty="0"/>
-              <a:t>- "Data Entry Error?" - "Values seem unusual, please double-check entry"</a:t>
-            </a:r>
-          </a:p>
-          <a:p>
-            <a:r>
-              <a:rPr lang="en-US" sz="1000" dirty="0"/>
-              <a:t>- Custom - Analyst writes own message</a:t>
-            </a:r>
-          </a:p>
-          <a:p>
-            <a:endParaRPr lang="en-US" sz="1000" dirty="0"/>
-          </a:p>
-          <a:p>
-            <a:r>
-              <a:rPr lang="en-US" sz="1000" dirty="0"/>
-              <a:t>QUEUE NAVIGATION:</a:t>
-            </a:r>
-          </a:p>
-          <a:p>
-            <a:r>
-              <a:rPr lang="en-US" sz="1000" dirty="0"/>
-              <a:t>- Sequential: Previous/Next buttons</a:t>
-            </a:r>
-          </a:p>
-          <a:p>
-            <a:r>
-              <a:rPr lang="en-US" sz="1000" dirty="0"/>
-              <a:t>- Jump to: Dropdown showing all queued items</a:t>
-            </a:r>
-          </a:p>
-          <a:p>
-            <a:r>
-              <a:rPr lang="en-US" sz="1000" dirty="0"/>
-              <a:t>- Return to overview: Back button</a:t>
-            </a:r>
-          </a:p>
-          <a:p>
-            <a:r>
-              <a:rPr lang="en-US" sz="1000" dirty="0"/>
-              <a:t>- Auto-advance after Approve (configurable in settings)</a:t>
-            </a:r>
-          </a:p>
-          <a:p>
-            <a:endParaRPr lang="en-US" sz="1000" dirty="0"/>
-          </a:p>
-          <a:p>
-            <a:r>
-              <a:rPr lang="en-US" sz="1000" dirty="0"/>
-              <a:t>PRIORITY CALCULATION:</a:t>
-            </a:r>
-          </a:p>
-          <a:p>
-            <a:r>
-              <a:rPr lang="en-US" sz="1000" dirty="0"/>
-              <a:t>- Critical: Multiple flags OR variance &gt;50%</a:t>
-            </a:r>
-          </a:p>
-          <a:p>
-            <a:r>
-              <a:rPr lang="en-US" sz="1000" dirty="0"/>
-              <a:t>- High: Single anomaly flag OR variance &gt;25%</a:t>
-            </a:r>
-          </a:p>
-          <a:p>
-            <a:r>
-              <a:rPr lang="en-US" sz="1000" dirty="0"/>
-              <a:t>- Medium: Budget variance OR missing data</a:t>
-            </a:r>
-          </a:p>
-          <a:p>
-            <a:r>
-              <a:rPr lang="en-US" sz="1000" dirty="0"/>
-              <a:t>- Low: Format issues OR minor discrepancies</a:t>
-            </a:r>
-          </a:p>
-          <a:p>
-            <a:endParaRPr lang="en-US" sz="1000" dirty="0"/>
-          </a:p>
-          <a:p>
-            <a:r>
-              <a:rPr lang="en-US" sz="1000" dirty="0"/>
-              <a:t>COMPARISON DATA SOURCES:</a:t>
-            </a:r>
-          </a:p>
-          <a:p>
-            <a:r>
-              <a:rPr lang="en-US" sz="1000" dirty="0"/>
-              <a:t>- Budget: Most recent submission where </a:t>
-            </a:r>
-            <a:r>
-              <a:rPr lang="en-US" sz="1000" dirty="0" err="1"/>
-              <a:t>BudgetVolume</a:t>
-            </a:r>
-            <a:r>
-              <a:rPr lang="en-US" sz="1000" dirty="0"/>
-              <a:t> IS NOT NULL for that test/country</a:t>
-            </a:r>
-          </a:p>
-          <a:p>
-            <a:r>
-              <a:rPr lang="en-US" sz="1000" dirty="0"/>
-              <a:t>- Prior Month: </a:t>
-            </a:r>
-            <a:r>
-              <a:rPr lang="en-US" sz="1000" dirty="0" err="1"/>
-              <a:t>VolumeSubmissions</a:t>
-            </a:r>
-            <a:r>
-              <a:rPr lang="en-US" sz="1000" dirty="0"/>
-              <a:t> WHERE </a:t>
-            </a:r>
-            <a:r>
-              <a:rPr lang="en-US" sz="1000" dirty="0" err="1"/>
-              <a:t>SubmissionMonth</a:t>
-            </a:r>
-            <a:r>
-              <a:rPr lang="en-US" sz="1000" dirty="0"/>
-              <a:t> = [Current Month - 1 month]</a:t>
-            </a:r>
-          </a:p>
-          <a:p>
-            <a:r>
-              <a:rPr lang="en-US" sz="1000" dirty="0"/>
-              <a:t>- Historical Avg: AVG of </a:t>
-            </a:r>
-            <a:r>
-              <a:rPr lang="en-US" sz="1000" dirty="0" err="1"/>
-              <a:t>ActualVolume</a:t>
-            </a:r>
-            <a:r>
-              <a:rPr lang="en-US" sz="1000" dirty="0"/>
-              <a:t> for past 6 months (if available)</a:t>
-            </a:r>
-          </a:p>
-          <a:p>
-            <a:endParaRPr lang="en-US" sz="1000" dirty="0"/>
-          </a:p>
-          <a:p>
-            <a:r>
-              <a:rPr lang="en-US" sz="1000" dirty="0"/>
-              <a:t>TOLERANCE THRESHOLDS:</a:t>
-            </a:r>
-          </a:p>
-          <a:p>
-            <a:r>
-              <a:rPr lang="en-US" sz="1000" dirty="0"/>
-              <a:t>- Pulled from </a:t>
-            </a:r>
-            <a:r>
-              <a:rPr lang="en-US" sz="1000" dirty="0" err="1"/>
-              <a:t>tbl_SystemConfig</a:t>
-            </a:r>
-            <a:endParaRPr lang="en-US" sz="1000" dirty="0"/>
-          </a:p>
-          <a:p>
-            <a:r>
-              <a:rPr lang="en-US" sz="1000" dirty="0"/>
-              <a:t>- </a:t>
-            </a:r>
-            <a:r>
-              <a:rPr lang="en-US" sz="1000" dirty="0" err="1"/>
-              <a:t>AnomalyThresholdPct</a:t>
-            </a:r>
-            <a:r>
-              <a:rPr lang="en-US" sz="1000" dirty="0"/>
-              <a:t> (default 50%)</a:t>
-            </a:r>
-          </a:p>
-          <a:p>
-            <a:r>
-              <a:rPr lang="en-US" sz="1000" dirty="0"/>
-              <a:t>- </a:t>
-            </a:r>
-            <a:r>
-              <a:rPr lang="en-US" sz="1000" dirty="0" err="1"/>
-              <a:t>BudgetVarianceThresholdPct</a:t>
-            </a:r>
-            <a:r>
-              <a:rPr lang="en-US" sz="1000" dirty="0"/>
-              <a:t> (default 25%)</a:t>
-            </a:r>
-          </a:p>
-          <a:p>
-            <a:r>
-              <a:rPr lang="en-US" sz="1000" dirty="0"/>
-              <a:t>- Configurable by test type (some tests more volatile)</a:t>
-            </a:r>
-          </a:p>
-          <a:p>
-            <a:endParaRPr lang="en-US" sz="1000" dirty="0"/>
-          </a:p>
-          <a:p>
-            <a:r>
-              <a:rPr lang="en-US" sz="1000" dirty="0"/>
-              <a:t>PERFORMANCE CONSIDERATIONS:</a:t>
-            </a:r>
-          </a:p>
-          <a:p>
-            <a:r>
-              <a:rPr lang="en-US" sz="1000" dirty="0"/>
-              <a:t>- Load comparison data when card displayed (not all at once)</a:t>
-            </a:r>
-          </a:p>
-          <a:p>
-            <a:r>
-              <a:rPr lang="en-US" sz="1000" dirty="0"/>
-              <a:t>- Cache prior month data (doesn't change)</a:t>
-            </a:r>
-          </a:p>
-          <a:p>
-            <a:r>
-              <a:rPr lang="en-US" sz="1000" dirty="0"/>
-              <a:t>- Prefetch next item in queue for faster navigation</a:t>
-            </a:r>
-          </a:p>
-          <a:p>
-            <a:r>
-              <a:rPr lang="en-US" sz="1000" dirty="0"/>
-              <a:t>- Limit historical analysis to 6 months (performance)</a:t>
-            </a:r>
-          </a:p>
-          <a:p>
-            <a:endParaRPr lang="en-US" sz="1000" dirty="0"/>
-          </a:p>
-          <a:p>
-            <a:r>
-              <a:rPr lang="en-US" sz="1000" dirty="0"/>
-              <a:t>KEYBOARD SHORTCUTS (Power User Feature):</a:t>
-            </a:r>
-          </a:p>
-          <a:p>
-            <a:r>
-              <a:rPr lang="en-US" sz="1000" dirty="0"/>
-              <a:t>- </a:t>
-            </a:r>
-            <a:r>
-              <a:rPr lang="en-US" sz="1000" dirty="0" err="1"/>
-              <a:t>Ctrl+A</a:t>
-            </a:r>
-            <a:r>
-              <a:rPr lang="en-US" sz="1000" dirty="0"/>
-              <a:t>: Approve &amp; Continue</a:t>
-            </a:r>
-          </a:p>
-          <a:p>
-            <a:r>
-              <a:rPr lang="en-US" sz="1000" dirty="0"/>
-              <a:t>- </a:t>
-            </a:r>
-            <a:r>
-              <a:rPr lang="en-US" sz="1000" dirty="0" err="1"/>
-              <a:t>Ctrl+R</a:t>
-            </a:r>
-            <a:r>
-              <a:rPr lang="en-US" sz="1000" dirty="0"/>
-              <a:t>: Request Clarification</a:t>
-            </a:r>
-          </a:p>
-          <a:p>
-            <a:r>
-              <a:rPr lang="en-US" sz="1000" dirty="0"/>
-              <a:t>- </a:t>
-            </a:r>
-            <a:r>
-              <a:rPr lang="en-US" sz="1000" dirty="0" err="1"/>
-              <a:t>Ctrl+E</a:t>
-            </a:r>
-            <a:r>
-              <a:rPr lang="en-US" sz="1000" dirty="0"/>
-              <a:t>: Manual Adjust</a:t>
-            </a:r>
-          </a:p>
-          <a:p>
-            <a:r>
-              <a:rPr lang="en-US" sz="1000" dirty="0"/>
-              <a:t>- </a:t>
-            </a:r>
-            <a:r>
-              <a:rPr lang="en-US" sz="1000" dirty="0" err="1"/>
-              <a:t>Ctrl+S</a:t>
-            </a:r>
-            <a:r>
-              <a:rPr lang="en-US" sz="1000" dirty="0"/>
-              <a:t>: Skip</a:t>
-            </a:r>
-          </a:p>
-          <a:p>
-            <a:r>
-              <a:rPr lang="en-US" sz="1000" dirty="0"/>
-              <a:t>- Arrow keys: Previous/Next</a:t>
-            </a:r>
-          </a:p>
-          <a:p>
-            <a:r>
-              <a:rPr lang="en-US" sz="1000" dirty="0"/>
-              <a:t>- </a:t>
-            </a:r>
-            <a:r>
-              <a:rPr lang="en-US" sz="1000" dirty="0" err="1"/>
-              <a:t>Ctrl+H</a:t>
-            </a:r>
-            <a:r>
-              <a:rPr lang="en-US" sz="1000" dirty="0"/>
-              <a:t>: View full submission history</a:t>
-            </a:r>
-          </a:p>
-          <a:p>
-            <a:endParaRPr lang="en-US" sz="1000" dirty="0"/>
-          </a:p>
-          <a:p>
-            <a:r>
-              <a:rPr lang="en-US" sz="1000" dirty="0"/>
-              <a:t>EMAIL NOTIFICATIONS:</a:t>
-            </a:r>
-          </a:p>
-          <a:p>
-            <a:r>
-              <a:rPr lang="en-US" sz="1000" dirty="0"/>
-              <a:t>- Approved: "Your submission for [Country] [Month] has been validated"</a:t>
-            </a:r>
-          </a:p>
-          <a:p>
-            <a:r>
-              <a:rPr lang="en-US" sz="1000" dirty="0"/>
-              <a:t>- Clarification: "Questions about your [Month] submission" (includes analyst message)</a:t>
-            </a:r>
-          </a:p>
-          <a:p>
-            <a:r>
-              <a:rPr lang="en-US" sz="1000" dirty="0"/>
-              <a:t>- Manually Adjusted: "Your submission has been adjusted by analyst" (includes what changed)</a:t>
-            </a:r>
-          </a:p>
-          <a:p>
-            <a:endParaRPr lang="en-US" sz="1000" dirty="0"/>
-          </a:p>
-          <a:p>
-            <a:r>
-              <a:rPr lang="en-US" sz="1000" dirty="0"/>
-              <a:t>POWER APPS IMPLEMENTATION:</a:t>
-            </a:r>
-          </a:p>
-          <a:p>
-            <a:r>
-              <a:rPr lang="en-US" sz="1000" dirty="0"/>
-              <a:t>- Form control (not Gallery) for focused one-at-a-time review</a:t>
-            </a:r>
-          </a:p>
-          <a:p>
-            <a:r>
-              <a:rPr lang="en-US" sz="1000" dirty="0"/>
-              <a:t>- Context variable: </a:t>
-            </a:r>
-            <a:r>
-              <a:rPr lang="en-US" sz="1000" dirty="0" err="1"/>
-              <a:t>varCurrentReviewItem</a:t>
-            </a:r>
-            <a:endParaRPr lang="en-US" sz="1000" dirty="0"/>
-          </a:p>
-          <a:p>
-            <a:r>
-              <a:rPr lang="en-US" sz="1000" dirty="0"/>
-              <a:t>- Navigate with </a:t>
-            </a:r>
-            <a:r>
-              <a:rPr lang="en-US" sz="1000" dirty="0" err="1"/>
-              <a:t>UpdateContext</a:t>
-            </a:r>
-            <a:r>
-              <a:rPr lang="en-US" sz="1000" dirty="0"/>
-              <a:t> to change current item</a:t>
-            </a:r>
-          </a:p>
-          <a:p>
-            <a:r>
-              <a:rPr lang="en-US" sz="1000" dirty="0"/>
-              <a:t>- Patch() for status updates</a:t>
-            </a:r>
-          </a:p>
-          <a:p>
-            <a:r>
-              <a:rPr lang="en-US" sz="1000" dirty="0"/>
-              <a:t>- Concurrent() for multiple table updates (submission + flags + history)</a:t>
-            </a:r>
-          </a:p>
-          <a:p>
-            <a:r>
-              <a:rPr lang="en-US" sz="1000" dirty="0"/>
-              <a:t>- Collection for queue (</a:t>
-            </a:r>
-            <a:r>
-              <a:rPr lang="en-US" sz="1000" dirty="0" err="1"/>
-              <a:t>colReviewQueue</a:t>
-            </a:r>
-            <a:r>
-              <a:rPr lang="en-US" sz="1000" dirty="0"/>
-              <a:t>) - refresh after each action</a:t>
-            </a:r>
-          </a:p>
-          <a:p>
-            <a:r>
-              <a:rPr lang="en-US" sz="1000" dirty="0"/>
-              <a:t>- Filtered Gallery on right showing remaining queue items</a:t>
-            </a:r>
-          </a:p>
-          <a:p>
-            <a:r>
-              <a:rPr lang="en-US" sz="1000" dirty="0"/>
-              <a:t>- Timer for session tracking (how long on each review)</a:t>
-            </a:r>
-          </a:p>
-          <a:p>
-            <a:endParaRPr lang="en-US" sz="1000" dirty="0"/>
-          </a:p>
-          <a:p>
-            <a:r>
-              <a:rPr lang="en-US" sz="1000" dirty="0"/>
-              <a:t>ACCESSIBILITY:</a:t>
-            </a:r>
-          </a:p>
-          <a:p>
-            <a:r>
-              <a:rPr lang="en-US" sz="1000" dirty="0"/>
-              <a:t>- Tab order: Card header → Comparison table → Notes → Actions</a:t>
-            </a:r>
-          </a:p>
-          <a:p>
-            <a:r>
-              <a:rPr lang="en-US" sz="1000" dirty="0"/>
-              <a:t>- Screen reader labels on all buttons</a:t>
-            </a:r>
-          </a:p>
-          <a:p>
-            <a:r>
-              <a:rPr lang="en-US" sz="1000" dirty="0"/>
-              <a:t>- Keyboard navigation throughout</a:t>
-            </a:r>
-          </a:p>
-          <a:p>
-            <a:r>
-              <a:rPr lang="en-US" sz="1000" dirty="0"/>
-              <a:t>- High contrast mode support</a:t>
-            </a:r>
           </a:p>
         </p:txBody>
       </p:sp>
@@ -19849,7 +18204,7 @@
         <p:spPr>
           <a:xfrm>
             <a:off x="3982065" y="681676"/>
-            <a:ext cx="3431459" cy="6093976"/>
+            <a:ext cx="3431459" cy="6247864"/>
           </a:xfrm>
           <a:prstGeom prst="rect">
             <a:avLst/>
@@ -20051,6 +18406,9 @@
               <a:rPr lang="en-US" sz="1000" dirty="0"/>
               <a:t>_[Month]_[Date].xlsx"</a:t>
             </a:r>
+          </a:p>
+          <a:p>
+            <a:endParaRPr lang="en-US" sz="1000" dirty="0"/>
           </a:p>
           <a:p>
             <a:endParaRPr lang="en-US" sz="1000" dirty="0"/>
@@ -20072,7 +18430,7 @@
         <p:spPr>
           <a:xfrm>
             <a:off x="7413524" y="681676"/>
-            <a:ext cx="3431459" cy="6247864"/>
+            <a:ext cx="3431459" cy="5478423"/>
           </a:xfrm>
           <a:prstGeom prst="rect">
             <a:avLst/>
@@ -20084,33 +18442,6 @@
             <a:spAutoFit/>
           </a:bodyPr>
           <a:lstStyle/>
-          <a:p>
-            <a:r>
-              <a:rPr lang="en-US" sz="1000" dirty="0"/>
-              <a:t>Alert Box Logic:</a:t>
-            </a:r>
-          </a:p>
-          <a:p>
-            <a:r>
-              <a:rPr lang="en-US" sz="1000" dirty="0"/>
-              <a:t>- Appears only if there are items needing attention</a:t>
-            </a:r>
-          </a:p>
-          <a:p>
-            <a:r>
-              <a:rPr lang="en-US" sz="1000" dirty="0"/>
-              <a:t>- Flagged count &gt; 0 OR Not Started count &gt; threshold</a:t>
-            </a:r>
-          </a:p>
-          <a:p>
-            <a:r>
-              <a:rPr lang="en-US" sz="1000" dirty="0"/>
-              <a:t>- Clickable - links to relevant items</a:t>
-            </a:r>
-          </a:p>
-          <a:p>
-            <a:endParaRPr lang="en-US" sz="1000" dirty="0"/>
-          </a:p>
           <a:p>
             <a:r>
               <a:rPr lang="en-US" sz="1000" dirty="0"/>

</xml_diff>